<commit_message>
talk(banca): slide do ciclo do AG e NSGA-II em destaque
Novo slide 6 com o ciclo do AG (população, avaliação, seleção, variação),
que planta o que os resultados cobram: o ruído do desequilíbrio (slide 13)
e o passo 4× menor dos pesos (slide 11). O antigo slide 6 vira o 7, centrado
no NSGA-II: diagrama de dominância de Pareto, o extremo de menor desvio que
nunca é descartado (slide 14), híbrido e controle em cartões menores e o
protocolo no rodapé. Deck com 17 slides de fala e 13 reservas.

Roteiro: falas dos slides 6 e 7, tempos refeitos (1593 palavras, 10:37 a
150 ppm), lista de cortes de ~53 s, duas perguntas novas e checklist do
Google Slides. Guia de estudo: seção slide a slide renumerada.

Co-Authored-By: Claude Opus 5.5 <noreply@anthropic.com>
</commit_message>
<xml_diff>
--- a/overleaf/talk-committee-2026/slides.pptx
+++ b/overleaf/talk-committee-2026/slides.pptx
@@ -10,6 +10,7 @@
     <p:sldId id="258" r:id="rId10"/>
     <p:sldId id="259" r:id="rId11"/>
     <p:sldId id="260" r:id="rId12"/>
+    <p:sldId id="285" r:id="rId37"/>
     <p:sldId id="261" r:id="rId13"/>
     <p:sldId id="262" r:id="rId14"/>
     <p:sldId id="263" r:id="rId15"/>
@@ -975,6 +976,76 @@
 </p:notes>
 </file>
 
+<file path=ppt/notesSlides/notesSlide16.xml><?xml version="1.0" encoding="utf-8"?>
+<p:notes xmlns:a="http://schemas.openxmlformats.org/drawingml/2006/main" xmlns:p="http://schemas.openxmlformats.org/presentationml/2006/main" xmlns:r="http://schemas.openxmlformats.org/officeDocument/2006/relationships">
+  <p:cSld>
+    <p:spTree>
+      <p:nvGrpSpPr>
+        <p:cNvPr id="1" name=""/>
+        <p:cNvGrpSpPr/>
+        <p:nvPr/>
+      </p:nvGrpSpPr>
+      <p:grpSpPr>
+        <a:xfrm>
+          <a:off x="0" y="0"/>
+          <a:ext cx="0" cy="0"/>
+          <a:chOff x="0" y="0"/>
+          <a:chExt cx="0" cy="0"/>
+        </a:xfrm>
+      </p:grpSpPr>
+      <p:sp>
+        <p:nvSpPr>
+          <p:cNvPr id="2" name="Slide Image Placeholder 1"/>
+          <p:cNvSpPr>
+            <a:spLocks noGrp="1"/>
+          </p:cNvSpPr>
+          <p:nvPr>
+            <p:ph type="sldImg" idx="2"/>
+          </p:nvPr>
+        </p:nvSpPr>
+        <p:spPr/>
+      </p:sp>
+      <p:sp>
+        <p:nvSpPr>
+          <p:cNvPr id="3" name="Notes Placeholder 2"/>
+          <p:cNvSpPr>
+            <a:spLocks noGrp="1"/>
+          </p:cNvSpPr>
+          <p:nvPr>
+            <p:ph type="body" idx="3" sz="quarter"/>
+          </p:nvPr>
+        </p:nvSpPr>
+        <p:spPr/>
+        <p:txBody>
+          <a:bodyPr/>
+          <a:lstStyle/>
+          <a:p>
+            <a:r>
+              <a:t>Com a aptidão definida, o algoritmo genético repete um ciclo. A população tem 300 elencos: na geração zero, o canônico e 299 sorteados. Cada elenco é avaliado no round-robin. O desvio sai direto dos genes, mas o desequilíbrio sai das lutas, e os sorteios mudam a cada geração, para que a busca não se ajuste a eles. Por isso, o desequilíbrio é sempre uma estimativa com ruído. Os 10% melhores passam direto, e cada pai é o melhor de um torneio de três. O cruzamento passa cada personagem inteiro de um dos pais, e a mutação perturba alguns genes, com passo quatro vezes menor nos pesos. Isso se repete por 150 gerações.</a:t>
+            </a:r>
+          </a:p>
+        </p:txBody>
+      </p:sp>
+      <p:sp>
+        <p:nvSpPr>
+          <p:cNvPr id="4" name="Slide Number Placeholder 3"/>
+          <p:cNvSpPr>
+            <a:spLocks noGrp="1"/>
+          </p:cNvSpPr>
+          <p:nvPr>
+            <p:ph type="sldNum" idx="5" sz="quarter"/>
+          </p:nvPr>
+        </p:nvSpPr>
+        <p:spPr/>
+      </p:sp>
+    </p:spTree>
+  </p:cSld>
+  <p:clrMapOvr>
+    <a:masterClrMapping/>
+  </p:clrMapOvr>
+</p:notes>
+</file>
+
 <file path=ppt/notesSlides/notesSlide2.xml><?xml version="1.0" encoding="utf-8"?>
 <p:notes xmlns:a="http://schemas.openxmlformats.org/drawingml/2006/main" xmlns:p="http://schemas.openxmlformats.org/presentationml/2006/main" xmlns:r="http://schemas.openxmlformats.org/officeDocument/2006/relationships">
   <p:cSld>
@@ -1300,7 +1371,7 @@
           <a:lstStyle/>
           <a:p>
             <a:r>
-              <a:t>Comparamos três algoritmos com o mesmo orçamento, de 300 elencos por 150 gerações. O algoritmo escalar soma os dois termos e devolve um elenco. O NSGA-II os trata como objetivos separados e devolve uma fronteira de Pareto. O híbrido roda o NSGA-II na primeira metade e entrega a fronteira ao escalar na segunda. O controle principal é o próprio escalar sem o termo de identidade, porque é ele que isola o efeito do método. Cada braço rodou vinte vezes com as mesmas sementes, e as comparações usam Wilcoxon pareado com correção de Holm. Os elencos finais são reavaliados com mil lutas por par, em sorteios inéditos, e lidos contra 35 elencos nulos.</a:t>
+              <a:t>O NSGA-II usa o mesmo ciclo, com outra seleção. Em vez de somar os dois termos, ele compara por dominância: um elenco domina outro se não é pior em nenhum dos dois e é melhor em pelo menos um. Os que ninguém domina formam a fronteira, e, entre eles, a seleção prefere os mais isolados, para espalhá-la. Uma consequência importa adiante: o elenco de menor desvio nunca é dominado, então nunca é descartado. A saída é a fronteira; para comparar, usamos o ponto dela que minimiza a mesma soma do escalar. Completam o desenho o híbrido, com o NSGA-II na primeira metade e o escalar na segunda, e o controle sem o termo de identidade. Cada braço rodou vinte vezes, com as mesmas sementes, e os elencos finais são reavaliados com mil lutas por par.</a:t>
             </a:r>
           </a:p>
         </p:txBody>
@@ -6808,7 +6879,7 @@
                 </a:solidFill>
                 <a:latin typeface="Open Sans"/>
               </a:rPr>
-              <a:t>10</a:t>
+              <a:t>11</a:t>
             </a:r>
           </a:p>
         </p:txBody>
@@ -8734,7 +8805,7 @@
                 </a:solidFill>
                 <a:latin typeface="Open Sans"/>
               </a:rPr>
-              <a:t>11</a:t>
+              <a:t>12</a:t>
             </a:r>
           </a:p>
         </p:txBody>
@@ -9301,7 +9372,7 @@
                 </a:solidFill>
                 <a:latin typeface="Open Sans"/>
               </a:rPr>
-              <a:t>12</a:t>
+              <a:t>13</a:t>
             </a:r>
           </a:p>
         </p:txBody>
@@ -9989,7 +10060,7 @@
                 </a:solidFill>
                 <a:latin typeface="Open Sans"/>
               </a:rPr>
-              <a:t>13</a:t>
+              <a:t>14</a:t>
             </a:r>
           </a:p>
         </p:txBody>
@@ -11690,7 +11761,7 @@
                 </a:solidFill>
                 <a:latin typeface="Open Sans"/>
               </a:rPr>
-              <a:t>14</a:t>
+              <a:t>15</a:t>
             </a:r>
           </a:p>
         </p:txBody>
@@ -12470,7 +12541,7 @@
                 </a:solidFill>
                 <a:latin typeface="Open Sans"/>
               </a:rPr>
-              <a:t>15</a:t>
+              <a:t>16</a:t>
             </a:r>
           </a:p>
         </p:txBody>
@@ -33368,6 +33439,1989 @@
 </p:sld>
 </file>
 
+<file path=ppt/slides/slide30.xml><?xml version="1.0" encoding="utf-8"?>
+<p:sld xmlns:a="http://schemas.openxmlformats.org/drawingml/2006/main" xmlns:p="http://schemas.openxmlformats.org/presentationml/2006/main" xmlns:r="http://schemas.openxmlformats.org/officeDocument/2006/relationships">
+  <p:cSld>
+    <p:spTree>
+      <p:nvGrpSpPr>
+        <p:cNvPr id="1" name=""/>
+        <p:cNvGrpSpPr/>
+        <p:nvPr/>
+      </p:nvGrpSpPr>
+      <p:grpSpPr/>
+      <p:sp>
+        <p:nvSpPr>
+          <p:cNvPr id="2" name="Cabeçalho"/>
+          <p:cNvSpPr/>
+          <p:nvPr/>
+        </p:nvSpPr>
+        <p:spPr>
+          <a:xfrm>
+            <a:off x="0" y="0"/>
+            <a:ext cx="12191695" cy="566928"/>
+          </a:xfrm>
+          <a:prstGeom prst="rect">
+            <a:avLst/>
+          </a:prstGeom>
+          <a:solidFill>
+            <a:srgbClr val="2F9E41"/>
+          </a:solidFill>
+          <a:ln>
+            <a:noFill/>
+          </a:ln>
+        </p:spPr>
+        <p:txBody>
+          <a:bodyPr rtlCol="0" anchor="ctr"/>
+          <a:lstStyle/>
+          <a:p>
+            <a:pPr algn="ctr"/>
+          </a:p>
+        </p:txBody>
+      </p:sp>
+      <p:pic>
+        <p:nvPicPr>
+          <p:cNvPr id="3" name="Marca Ifes" descr="logo_branco.png"/>
+          <p:cNvPicPr>
+            <a:picLocks noChangeAspect="1"/>
+          </p:cNvPicPr>
+          <p:nvPr/>
+        </p:nvPicPr>
+        <p:blipFill>
+          <a:blip r:embed="rId2"/>
+          <a:stretch>
+            <a:fillRect/>
+          </a:stretch>
+        </p:blipFill>
+        <p:spPr>
+          <a:xfrm>
+            <a:off x="411480" y="118872"/>
+            <a:ext cx="1371600" cy="329184"/>
+          </a:xfrm>
+          <a:prstGeom prst="rect">
+            <a:avLst/>
+          </a:prstGeom>
+        </p:spPr>
+      </p:pic>
+      <p:sp>
+        <p:nvSpPr>
+          <p:cNvPr id="4" name="Andamento"/>
+          <p:cNvSpPr txBox="1"/>
+          <p:nvPr/>
+        </p:nvSpPr>
+        <p:spPr>
+          <a:xfrm>
+            <a:off x="4572000" y="0"/>
+            <a:ext cx="7159752" cy="566928"/>
+          </a:xfrm>
+          <a:prstGeom prst="rect">
+            <a:avLst/>
+          </a:prstGeom>
+          <a:noFill/>
+        </p:spPr>
+        <p:txBody>
+          <a:bodyPr wrap="square" lIns="0" rIns="0" tIns="0" bIns="0" anchor="ctr">
+            <a:noAutofit/>
+          </a:bodyPr>
+          <a:lstStyle/>
+          <a:p>
+            <a:pPr algn="r">
+              <a:lnSpc>
+                <a:spcPct val="100000"/>
+              </a:lnSpc>
+              <a:spcBef>
+                <a:spcPts val="0"/>
+              </a:spcBef>
+              <a:spcAft>
+                <a:spcPts val="0"/>
+              </a:spcAft>
+            </a:pPr>
+            <a:r>
+              <a:rPr sz="1400" b="0" i="0">
+                <a:solidFill>
+                  <a:srgbClr val="BFE5C7"/>
+                </a:solidFill>
+                <a:latin typeface="Open Sans"/>
+              </a:rPr>
+              <a:t>Problema</a:t>
+            </a:r>
+            <a:r>
+              <a:rPr sz="1400" b="0" i="0">
+                <a:solidFill>
+                  <a:srgbClr val="BFE5C7"/>
+                </a:solidFill>
+                <a:latin typeface="Open Sans"/>
+              </a:rPr>
+              <a:t>     </a:t>
+            </a:r>
+            <a:r>
+              <a:rPr sz="1400" b="1" i="0">
+                <a:solidFill>
+                  <a:srgbClr val="FFFFFF"/>
+                </a:solidFill>
+                <a:latin typeface="Open Sans"/>
+              </a:rPr>
+              <a:t>Método</a:t>
+            </a:r>
+            <a:r>
+              <a:rPr sz="1400" b="0" i="0">
+                <a:solidFill>
+                  <a:srgbClr val="BFE5C7"/>
+                </a:solidFill>
+                <a:latin typeface="Open Sans"/>
+              </a:rPr>
+              <a:t>     </a:t>
+            </a:r>
+            <a:r>
+              <a:rPr sz="1400" b="0" i="0">
+                <a:solidFill>
+                  <a:srgbClr val="BFE5C7"/>
+                </a:solidFill>
+                <a:latin typeface="Open Sans"/>
+              </a:rPr>
+              <a:t>Resultados</a:t>
+            </a:r>
+            <a:r>
+              <a:rPr sz="1400" b="0" i="0">
+                <a:solidFill>
+                  <a:srgbClr val="BFE5C7"/>
+                </a:solidFill>
+                <a:latin typeface="Open Sans"/>
+              </a:rPr>
+              <a:t>     </a:t>
+            </a:r>
+            <a:r>
+              <a:rPr sz="1400" b="0" i="0">
+                <a:solidFill>
+                  <a:srgbClr val="BFE5C7"/>
+                </a:solidFill>
+                <a:latin typeface="Open Sans"/>
+              </a:rPr>
+              <a:t>Conclusão</a:t>
+            </a:r>
+          </a:p>
+        </p:txBody>
+      </p:sp>
+      <p:sp>
+        <p:nvSpPr>
+          <p:cNvPr id="5" name="Título"/>
+          <p:cNvSpPr txBox="1"/>
+          <p:nvPr/>
+        </p:nvSpPr>
+        <p:spPr>
+          <a:xfrm>
+            <a:off x="548640" y="804672"/>
+            <a:ext cx="11091672" cy="512064"/>
+          </a:xfrm>
+          <a:prstGeom prst="rect">
+            <a:avLst/>
+          </a:prstGeom>
+          <a:noFill/>
+        </p:spPr>
+        <p:txBody>
+          <a:bodyPr wrap="square" lIns="0" rIns="0" tIns="0" bIns="0" anchor="t">
+            <a:noAutofit/>
+          </a:bodyPr>
+          <a:lstStyle/>
+          <a:p>
+            <a:pPr algn="l">
+              <a:lnSpc>
+                <a:spcPct val="100000"/>
+              </a:lnSpc>
+              <a:spcBef>
+                <a:spcPts val="0"/>
+              </a:spcBef>
+              <a:spcAft>
+                <a:spcPts val="0"/>
+              </a:spcAft>
+            </a:pPr>
+            <a:r>
+              <a:rPr sz="2600" b="1" i="0">
+                <a:solidFill>
+                  <a:srgbClr val="17201B"/>
+                </a:solidFill>
+                <a:latin typeface="Open Sans"/>
+              </a:rPr>
+              <a:t>Um algoritmo genético evolui 300 elencos por 150 gerações</a:t>
+            </a:r>
+          </a:p>
+        </p:txBody>
+      </p:sp>
+      <p:sp>
+        <p:nvSpPr>
+          <p:cNvPr id="6" name="Número"/>
+          <p:cNvSpPr txBox="1"/>
+          <p:nvPr/>
+        </p:nvSpPr>
+        <p:spPr>
+          <a:xfrm>
+            <a:off x="11091672" y="6446520"/>
+            <a:ext cx="548640" cy="274320"/>
+          </a:xfrm>
+          <a:prstGeom prst="rect">
+            <a:avLst/>
+          </a:prstGeom>
+          <a:noFill/>
+        </p:spPr>
+        <p:txBody>
+          <a:bodyPr wrap="square" lIns="0" rIns="0" tIns="0" bIns="0" anchor="t">
+            <a:noAutofit/>
+          </a:bodyPr>
+          <a:lstStyle/>
+          <a:p>
+            <a:pPr algn="r">
+              <a:lnSpc>
+                <a:spcPct val="100000"/>
+              </a:lnSpc>
+              <a:spcBef>
+                <a:spcPts val="0"/>
+              </a:spcBef>
+              <a:spcAft>
+                <a:spcPts val="0"/>
+              </a:spcAft>
+            </a:pPr>
+            <a:r>
+              <a:rPr sz="1200" b="0" i="0">
+                <a:solidFill>
+                  <a:srgbClr val="6F7772"/>
+                </a:solidFill>
+                <a:latin typeface="Open Sans"/>
+              </a:rPr>
+              <a:t>6</a:t>
+            </a:r>
+          </a:p>
+        </p:txBody>
+      </p:sp>
+      <p:sp>
+        <p:nvSpPr>
+          <p:cNvPr id="7" name="Rounded Rectangle 6"/>
+          <p:cNvSpPr/>
+          <p:nvPr/>
+        </p:nvSpPr>
+        <p:spPr>
+          <a:xfrm>
+            <a:off x="548640" y="1709928"/>
+            <a:ext cx="5340096" cy="1778508"/>
+          </a:xfrm>
+          <a:prstGeom prst="roundRect">
+            <a:avLst>
+              <a:gd name="adj" fmla="val 6169"/>
+            </a:avLst>
+          </a:prstGeom>
+          <a:solidFill>
+            <a:srgbClr val="F2F4F3"/>
+          </a:solidFill>
+          <a:ln>
+            <a:noFill/>
+          </a:ln>
+        </p:spPr>
+        <p:txBody>
+          <a:bodyPr rtlCol="0" anchor="ctr"/>
+          <a:lstStyle/>
+          <a:p>
+            <a:pPr algn="ctr"/>
+          </a:p>
+        </p:txBody>
+      </p:sp>
+      <p:sp>
+        <p:nvSpPr>
+          <p:cNvPr id="8" name="Rounded Rectangle 7"/>
+          <p:cNvSpPr/>
+          <p:nvPr/>
+        </p:nvSpPr>
+        <p:spPr>
+          <a:xfrm>
+            <a:off x="6300216" y="1709928"/>
+            <a:ext cx="5340096" cy="1778508"/>
+          </a:xfrm>
+          <a:prstGeom prst="roundRect">
+            <a:avLst>
+              <a:gd name="adj" fmla="val 6169"/>
+            </a:avLst>
+          </a:prstGeom>
+          <a:solidFill>
+            <a:srgbClr val="F2F4F3"/>
+          </a:solidFill>
+          <a:ln>
+            <a:noFill/>
+          </a:ln>
+        </p:spPr>
+        <p:txBody>
+          <a:bodyPr rtlCol="0" anchor="ctr"/>
+          <a:lstStyle/>
+          <a:p>
+            <a:pPr algn="ctr"/>
+          </a:p>
+        </p:txBody>
+      </p:sp>
+      <p:sp>
+        <p:nvSpPr>
+          <p:cNvPr id="9" name="Rounded Rectangle 8"/>
+          <p:cNvSpPr/>
+          <p:nvPr/>
+        </p:nvSpPr>
+        <p:spPr>
+          <a:xfrm>
+            <a:off x="6300216" y="3872484"/>
+            <a:ext cx="5340096" cy="1778508"/>
+          </a:xfrm>
+          <a:prstGeom prst="roundRect">
+            <a:avLst>
+              <a:gd name="adj" fmla="val 6169"/>
+            </a:avLst>
+          </a:prstGeom>
+          <a:solidFill>
+            <a:srgbClr val="F2F4F3"/>
+          </a:solidFill>
+          <a:ln>
+            <a:noFill/>
+          </a:ln>
+        </p:spPr>
+        <p:txBody>
+          <a:bodyPr rtlCol="0" anchor="ctr"/>
+          <a:lstStyle/>
+          <a:p>
+            <a:pPr algn="ctr"/>
+          </a:p>
+        </p:txBody>
+      </p:sp>
+      <p:sp>
+        <p:nvSpPr>
+          <p:cNvPr id="10" name="Rounded Rectangle 9"/>
+          <p:cNvSpPr/>
+          <p:nvPr/>
+        </p:nvSpPr>
+        <p:spPr>
+          <a:xfrm>
+            <a:off x="548640" y="3872484"/>
+            <a:ext cx="5340096" cy="1778508"/>
+          </a:xfrm>
+          <a:prstGeom prst="roundRect">
+            <a:avLst>
+              <a:gd name="adj" fmla="val 6169"/>
+            </a:avLst>
+          </a:prstGeom>
+          <a:solidFill>
+            <a:srgbClr val="F2F4F3"/>
+          </a:solidFill>
+          <a:ln>
+            <a:noFill/>
+          </a:ln>
+        </p:spPr>
+        <p:txBody>
+          <a:bodyPr rtlCol="0" anchor="ctr"/>
+          <a:lstStyle/>
+          <a:p>
+            <a:pPr algn="ctr"/>
+          </a:p>
+        </p:txBody>
+      </p:sp>
+      <p:cxnSp>
+        <p:nvCxnSpPr>
+          <p:cNvPr id="11" name="Connector 10"/>
+          <p:cNvCxnSpPr/>
+          <p:nvPr/>
+        </p:nvCxnSpPr>
+        <p:spPr>
+          <a:xfrm>
+            <a:off x="5952744" y="2599182"/>
+            <a:ext cx="283463" cy="0"/>
+          </a:xfrm>
+          <a:prstGeom prst="line">
+            <a:avLst/>
+          </a:prstGeom>
+          <a:ln w="28575">
+            <a:solidFill>
+              <a:srgbClr val="6F7772"/>
+            </a:solidFill>
+            <a:tailEnd type="triangle" w="med" len="med"/>
+          </a:ln>
+        </p:spPr>
+      </p:cxnSp>
+      <p:cxnSp>
+        <p:nvCxnSpPr>
+          <p:cNvPr id="12" name="Connector 11"/>
+          <p:cNvCxnSpPr/>
+          <p:nvPr/>
+        </p:nvCxnSpPr>
+        <p:spPr>
+          <a:xfrm>
+            <a:off x="8970263" y="3543300"/>
+            <a:ext cx="0" cy="274320"/>
+          </a:xfrm>
+          <a:prstGeom prst="line">
+            <a:avLst/>
+          </a:prstGeom>
+          <a:ln w="28575">
+            <a:solidFill>
+              <a:srgbClr val="6F7772"/>
+            </a:solidFill>
+            <a:tailEnd type="triangle" w="med" len="med"/>
+          </a:ln>
+        </p:spPr>
+      </p:cxnSp>
+      <p:cxnSp>
+        <p:nvCxnSpPr>
+          <p:cNvPr id="13" name="Connector 12"/>
+          <p:cNvCxnSpPr/>
+          <p:nvPr/>
+        </p:nvCxnSpPr>
+        <p:spPr>
+          <a:xfrm flipH="1">
+            <a:off x="5952744" y="4761738"/>
+            <a:ext cx="283463" cy="0"/>
+          </a:xfrm>
+          <a:prstGeom prst="line">
+            <a:avLst/>
+          </a:prstGeom>
+          <a:ln w="28575">
+            <a:solidFill>
+              <a:srgbClr val="6F7772"/>
+            </a:solidFill>
+            <a:tailEnd type="triangle" w="med" len="med"/>
+          </a:ln>
+        </p:spPr>
+      </p:cxnSp>
+      <p:cxnSp>
+        <p:nvCxnSpPr>
+          <p:cNvPr id="14" name="Connector 13"/>
+          <p:cNvCxnSpPr/>
+          <p:nvPr/>
+        </p:nvCxnSpPr>
+        <p:spPr>
+          <a:xfrm flipV="1">
+            <a:off x="3218688" y="3543300"/>
+            <a:ext cx="0" cy="274320"/>
+          </a:xfrm>
+          <a:prstGeom prst="line">
+            <a:avLst/>
+          </a:prstGeom>
+          <a:ln w="28575">
+            <a:solidFill>
+              <a:srgbClr val="6F7772"/>
+            </a:solidFill>
+            <a:tailEnd type="triangle" w="med" len="med"/>
+          </a:ln>
+        </p:spPr>
+      </p:cxnSp>
+      <p:sp>
+        <p:nvSpPr>
+          <p:cNvPr id="15" name="Oval 14"/>
+          <p:cNvSpPr/>
+          <p:nvPr/>
+        </p:nvSpPr>
+        <p:spPr>
+          <a:xfrm>
+            <a:off x="5614415" y="3200400"/>
+            <a:ext cx="960120" cy="960120"/>
+          </a:xfrm>
+          <a:prstGeom prst="ellipse">
+            <a:avLst/>
+          </a:prstGeom>
+          <a:solidFill>
+            <a:srgbClr val="FFFFFF"/>
+          </a:solidFill>
+          <a:ln w="19050">
+            <a:solidFill>
+              <a:srgbClr val="6F7772"/>
+            </a:solidFill>
+          </a:ln>
+        </p:spPr>
+        <p:txBody>
+          <a:bodyPr rtlCol="0" anchor="ctr"/>
+          <a:lstStyle/>
+          <a:p>
+            <a:pPr algn="ctr"/>
+          </a:p>
+        </p:txBody>
+      </p:sp>
+      <p:sp>
+        <p:nvSpPr>
+          <p:cNvPr id="16" name="TextBox 15"/>
+          <p:cNvSpPr txBox="1"/>
+          <p:nvPr/>
+        </p:nvSpPr>
+        <p:spPr>
+          <a:xfrm>
+            <a:off x="5637275" y="3351276"/>
+            <a:ext cx="914400" cy="658368"/>
+          </a:xfrm>
+          <a:prstGeom prst="rect">
+            <a:avLst/>
+          </a:prstGeom>
+          <a:noFill/>
+        </p:spPr>
+        <p:txBody>
+          <a:bodyPr wrap="square" lIns="0" rIns="0" tIns="0" bIns="0" anchor="ctr">
+            <a:noAutofit/>
+          </a:bodyPr>
+          <a:lstStyle/>
+          <a:p>
+            <a:pPr algn="ctr">
+              <a:lnSpc>
+                <a:spcPct val="100000"/>
+              </a:lnSpc>
+              <a:spcBef>
+                <a:spcPts val="0"/>
+              </a:spcBef>
+              <a:spcAft>
+                <a:spcPts val="0"/>
+              </a:spcAft>
+            </a:pPr>
+            <a:r>
+              <a:rPr sz="2200" b="1" i="0">
+                <a:solidFill>
+                  <a:srgbClr val="17201B"/>
+                </a:solidFill>
+                <a:latin typeface="Open Sans"/>
+              </a:rPr>
+              <a:t>150</a:t>
+            </a:r>
+          </a:p>
+          <a:p>
+            <a:pPr algn="ctr">
+              <a:lnSpc>
+                <a:spcPct val="100000"/>
+              </a:lnSpc>
+              <a:spcBef>
+                <a:spcPts val="0"/>
+              </a:spcBef>
+              <a:spcAft>
+                <a:spcPts val="0"/>
+              </a:spcAft>
+            </a:pPr>
+            <a:r>
+              <a:rPr sz="1200" b="0" i="0">
+                <a:solidFill>
+                  <a:srgbClr val="4A524D"/>
+                </a:solidFill>
+                <a:latin typeface="Open Sans"/>
+              </a:rPr>
+              <a:t>gerações</a:t>
+            </a:r>
+          </a:p>
+        </p:txBody>
+      </p:sp>
+      <p:sp>
+        <p:nvSpPr>
+          <p:cNvPr id="17" name="TextBox 16"/>
+          <p:cNvSpPr txBox="1"/>
+          <p:nvPr/>
+        </p:nvSpPr>
+        <p:spPr>
+          <a:xfrm>
+            <a:off x="822959" y="1847088"/>
+            <a:ext cx="3657600" cy="310896"/>
+          </a:xfrm>
+          <a:prstGeom prst="rect">
+            <a:avLst/>
+          </a:prstGeom>
+          <a:noFill/>
+        </p:spPr>
+        <p:txBody>
+          <a:bodyPr wrap="square" lIns="0" rIns="0" tIns="0" bIns="0" anchor="t">
+            <a:noAutofit/>
+          </a:bodyPr>
+          <a:lstStyle/>
+          <a:p>
+            <a:pPr algn="l">
+              <a:lnSpc>
+                <a:spcPct val="100000"/>
+              </a:lnSpc>
+              <a:spcBef>
+                <a:spcPts val="0"/>
+              </a:spcBef>
+              <a:spcAft>
+                <a:spcPts val="0"/>
+              </a:spcAft>
+            </a:pPr>
+            <a:r>
+              <a:rPr sz="1500" b="1" i="0">
+                <a:solidFill>
+                  <a:srgbClr val="2F9E41"/>
+                </a:solidFill>
+                <a:latin typeface="Open Sans"/>
+              </a:rPr>
+              <a:t>1  POPULAÇÃO</a:t>
+            </a:r>
+          </a:p>
+        </p:txBody>
+      </p:sp>
+      <p:sp>
+        <p:nvSpPr>
+          <p:cNvPr id="18" name="TextBox 17"/>
+          <p:cNvSpPr txBox="1"/>
+          <p:nvPr/>
+        </p:nvSpPr>
+        <p:spPr>
+          <a:xfrm>
+            <a:off x="822959" y="2185416"/>
+            <a:ext cx="1463040" cy="694944"/>
+          </a:xfrm>
+          <a:prstGeom prst="rect">
+            <a:avLst/>
+          </a:prstGeom>
+          <a:noFill/>
+        </p:spPr>
+        <p:txBody>
+          <a:bodyPr wrap="square" lIns="0" rIns="0" tIns="0" bIns="0" anchor="t">
+            <a:noAutofit/>
+          </a:bodyPr>
+          <a:lstStyle/>
+          <a:p>
+            <a:pPr algn="l">
+              <a:lnSpc>
+                <a:spcPct val="100000"/>
+              </a:lnSpc>
+              <a:spcBef>
+                <a:spcPts val="0"/>
+              </a:spcBef>
+              <a:spcAft>
+                <a:spcPts val="0"/>
+              </a:spcAft>
+            </a:pPr>
+            <a:r>
+              <a:rPr sz="4000" b="1" i="0">
+                <a:solidFill>
+                  <a:srgbClr val="17201B"/>
+                </a:solidFill>
+                <a:latin typeface="Open Sans"/>
+              </a:rPr>
+              <a:t>300</a:t>
+            </a:r>
+          </a:p>
+        </p:txBody>
+      </p:sp>
+      <p:sp>
+        <p:nvSpPr>
+          <p:cNvPr id="19" name="TextBox 18"/>
+          <p:cNvSpPr txBox="1"/>
+          <p:nvPr/>
+        </p:nvSpPr>
+        <p:spPr>
+          <a:xfrm>
+            <a:off x="822959" y="2862072"/>
+            <a:ext cx="1463040" cy="292608"/>
+          </a:xfrm>
+          <a:prstGeom prst="rect">
+            <a:avLst/>
+          </a:prstGeom>
+          <a:noFill/>
+        </p:spPr>
+        <p:txBody>
+          <a:bodyPr wrap="square" lIns="0" rIns="0" tIns="0" bIns="0" anchor="t">
+            <a:noAutofit/>
+          </a:bodyPr>
+          <a:lstStyle/>
+          <a:p>
+            <a:pPr algn="l">
+              <a:lnSpc>
+                <a:spcPct val="100000"/>
+              </a:lnSpc>
+              <a:spcBef>
+                <a:spcPts val="0"/>
+              </a:spcBef>
+              <a:spcAft>
+                <a:spcPts val="0"/>
+              </a:spcAft>
+            </a:pPr>
+            <a:r>
+              <a:rPr sz="1700" b="0" i="0">
+                <a:solidFill>
+                  <a:srgbClr val="4A524D"/>
+                </a:solidFill>
+                <a:latin typeface="Open Sans"/>
+              </a:rPr>
+              <a:t>elencos</a:t>
+            </a:r>
+          </a:p>
+        </p:txBody>
+      </p:sp>
+      <p:sp>
+        <p:nvSpPr>
+          <p:cNvPr id="20" name="TextBox 19"/>
+          <p:cNvSpPr txBox="1"/>
+          <p:nvPr/>
+        </p:nvSpPr>
+        <p:spPr>
+          <a:xfrm>
+            <a:off x="2468880" y="2276856"/>
+            <a:ext cx="3145536" cy="960120"/>
+          </a:xfrm>
+          <a:prstGeom prst="rect">
+            <a:avLst/>
+          </a:prstGeom>
+          <a:noFill/>
+        </p:spPr>
+        <p:txBody>
+          <a:bodyPr wrap="square" lIns="0" rIns="0" tIns="0" bIns="0" anchor="t">
+            <a:noAutofit/>
+          </a:bodyPr>
+          <a:lstStyle/>
+          <a:p>
+            <a:pPr algn="l">
+              <a:lnSpc>
+                <a:spcPct val="100000"/>
+              </a:lnSpc>
+              <a:spcBef>
+                <a:spcPts val="0"/>
+              </a:spcBef>
+              <a:spcAft>
+                <a:spcPts val="0"/>
+              </a:spcAft>
+            </a:pPr>
+            <a:r>
+              <a:rPr sz="1600" b="0" i="0">
+                <a:solidFill>
+                  <a:srgbClr val="17201B"/>
+                </a:solidFill>
+                <a:latin typeface="Open Sans"/>
+              </a:rPr>
+              <a:t>cada um com 5 personagens</a:t>
+            </a:r>
+          </a:p>
+          <a:p>
+            <a:pPr algn="l">
+              <a:lnSpc>
+                <a:spcPct val="100000"/>
+              </a:lnSpc>
+              <a:spcBef>
+                <a:spcPts val="600"/>
+              </a:spcBef>
+              <a:spcAft>
+                <a:spcPts val="0"/>
+              </a:spcAft>
+            </a:pPr>
+            <a:r>
+              <a:rPr sz="1600" b="0" i="0">
+                <a:solidFill>
+                  <a:srgbClr val="17201B"/>
+                </a:solidFill>
+                <a:latin typeface="Open Sans"/>
+              </a:rPr>
+              <a:t>na geração 0: o canônico e 299 sorteados</a:t>
+            </a:r>
+          </a:p>
+        </p:txBody>
+      </p:sp>
+      <p:sp>
+        <p:nvSpPr>
+          <p:cNvPr id="21" name="TextBox 20"/>
+          <p:cNvSpPr txBox="1"/>
+          <p:nvPr/>
+        </p:nvSpPr>
+        <p:spPr>
+          <a:xfrm>
+            <a:off x="6574536" y="1847088"/>
+            <a:ext cx="3657600" cy="310896"/>
+          </a:xfrm>
+          <a:prstGeom prst="rect">
+            <a:avLst/>
+          </a:prstGeom>
+          <a:noFill/>
+        </p:spPr>
+        <p:txBody>
+          <a:bodyPr wrap="square" lIns="0" rIns="0" tIns="0" bIns="0" anchor="t">
+            <a:noAutofit/>
+          </a:bodyPr>
+          <a:lstStyle/>
+          <a:p>
+            <a:pPr algn="l">
+              <a:lnSpc>
+                <a:spcPct val="100000"/>
+              </a:lnSpc>
+              <a:spcBef>
+                <a:spcPts val="0"/>
+              </a:spcBef>
+              <a:spcAft>
+                <a:spcPts val="0"/>
+              </a:spcAft>
+            </a:pPr>
+            <a:r>
+              <a:rPr sz="1500" b="1" i="0">
+                <a:solidFill>
+                  <a:srgbClr val="2F9E41"/>
+                </a:solidFill>
+                <a:latin typeface="Open Sans"/>
+              </a:rPr>
+              <a:t>2  AVALIAÇÃO</a:t>
+            </a:r>
+          </a:p>
+        </p:txBody>
+      </p:sp>
+      <p:sp>
+        <p:nvSpPr>
+          <p:cNvPr id="22" name="TextBox 21"/>
+          <p:cNvSpPr txBox="1"/>
+          <p:nvPr/>
+        </p:nvSpPr>
+        <p:spPr>
+          <a:xfrm>
+            <a:off x="6574536" y="2185416"/>
+            <a:ext cx="4791456" cy="640080"/>
+          </a:xfrm>
+          <a:prstGeom prst="rect">
+            <a:avLst/>
+          </a:prstGeom>
+          <a:noFill/>
+        </p:spPr>
+        <p:txBody>
+          <a:bodyPr wrap="square" lIns="0" rIns="0" tIns="0" bIns="0" anchor="t">
+            <a:noAutofit/>
+          </a:bodyPr>
+          <a:lstStyle/>
+          <a:p>
+            <a:pPr algn="l">
+              <a:lnSpc>
+                <a:spcPct val="100000"/>
+              </a:lnSpc>
+              <a:spcBef>
+                <a:spcPts val="0"/>
+              </a:spcBef>
+              <a:spcAft>
+                <a:spcPts val="0"/>
+              </a:spcAft>
+            </a:pPr>
+            <a:r>
+              <a:rPr sz="1600" b="0" i="0">
+                <a:solidFill>
+                  <a:srgbClr val="17201B"/>
+                </a:solidFill>
+                <a:latin typeface="Open Sans"/>
+              </a:rPr>
+              <a:t>round-robin: 10 confrontos × 150 lutas</a:t>
+            </a:r>
+          </a:p>
+          <a:p>
+            <a:pPr algn="l">
+              <a:lnSpc>
+                <a:spcPct val="100000"/>
+              </a:lnSpc>
+              <a:spcBef>
+                <a:spcPts val="400"/>
+              </a:spcBef>
+              <a:spcAft>
+                <a:spcPts val="0"/>
+              </a:spcAft>
+            </a:pPr>
+            <a:r>
+              <a:rPr sz="1600" b="1" i="0">
+                <a:solidFill>
+                  <a:srgbClr val="CD191E"/>
+                </a:solidFill>
+                <a:latin typeface="Open Sans"/>
+              </a:rPr>
+              <a:t>desequilíbrio</a:t>
+            </a:r>
+            <a:r>
+              <a:rPr sz="1600" b="0" i="0">
+                <a:solidFill>
+                  <a:srgbClr val="17201B"/>
+                </a:solidFill>
+                <a:latin typeface="Open Sans"/>
+              </a:rPr>
+              <a:t> das lutas  ·  </a:t>
+            </a:r>
+            <a:r>
+              <a:rPr sz="1600" b="1" i="0">
+                <a:solidFill>
+                  <a:srgbClr val="6E4BB8"/>
+                </a:solidFill>
+                <a:latin typeface="Open Sans"/>
+              </a:rPr>
+              <a:t>desvio</a:t>
+            </a:r>
+            <a:r>
+              <a:rPr sz="1600" b="0" i="0">
+                <a:solidFill>
+                  <a:srgbClr val="17201B"/>
+                </a:solidFill>
+                <a:latin typeface="Open Sans"/>
+              </a:rPr>
+              <a:t> dos genes</a:t>
+            </a:r>
+          </a:p>
+        </p:txBody>
+      </p:sp>
+      <p:sp>
+        <p:nvSpPr>
+          <p:cNvPr id="23" name="TextBox 22"/>
+          <p:cNvSpPr txBox="1"/>
+          <p:nvPr/>
+        </p:nvSpPr>
+        <p:spPr>
+          <a:xfrm>
+            <a:off x="6574536" y="2811780"/>
+            <a:ext cx="4791456" cy="530352"/>
+          </a:xfrm>
+          <a:prstGeom prst="rect">
+            <a:avLst/>
+          </a:prstGeom>
+          <a:noFill/>
+        </p:spPr>
+        <p:txBody>
+          <a:bodyPr wrap="square" lIns="0" rIns="0" tIns="0" bIns="0" anchor="t">
+            <a:noAutofit/>
+          </a:bodyPr>
+          <a:lstStyle/>
+          <a:p>
+            <a:pPr algn="l">
+              <a:lnSpc>
+                <a:spcPct val="100000"/>
+              </a:lnSpc>
+              <a:spcBef>
+                <a:spcPts val="0"/>
+              </a:spcBef>
+              <a:spcAft>
+                <a:spcPts val="0"/>
+              </a:spcAft>
+            </a:pPr>
+            <a:r>
+              <a:rPr sz="1500" b="1" i="0">
+                <a:solidFill>
+                  <a:srgbClr val="17201B"/>
+                </a:solidFill>
+                <a:latin typeface="Open Sans"/>
+              </a:rPr>
+              <a:t>sorteios novos a cada geração: o desequilíbrio tem ruído</a:t>
+            </a:r>
+          </a:p>
+        </p:txBody>
+      </p:sp>
+      <p:sp>
+        <p:nvSpPr>
+          <p:cNvPr id="24" name="TextBox 23"/>
+          <p:cNvSpPr txBox="1"/>
+          <p:nvPr/>
+        </p:nvSpPr>
+        <p:spPr>
+          <a:xfrm>
+            <a:off x="6574536" y="4009644"/>
+            <a:ext cx="3657600" cy="310896"/>
+          </a:xfrm>
+          <a:prstGeom prst="rect">
+            <a:avLst/>
+          </a:prstGeom>
+          <a:noFill/>
+        </p:spPr>
+        <p:txBody>
+          <a:bodyPr wrap="square" lIns="0" rIns="0" tIns="0" bIns="0" anchor="t">
+            <a:noAutofit/>
+          </a:bodyPr>
+          <a:lstStyle/>
+          <a:p>
+            <a:pPr algn="l">
+              <a:lnSpc>
+                <a:spcPct val="100000"/>
+              </a:lnSpc>
+              <a:spcBef>
+                <a:spcPts val="0"/>
+              </a:spcBef>
+              <a:spcAft>
+                <a:spcPts val="0"/>
+              </a:spcAft>
+            </a:pPr>
+            <a:r>
+              <a:rPr sz="1500" b="1" i="0">
+                <a:solidFill>
+                  <a:srgbClr val="2F9E41"/>
+                </a:solidFill>
+                <a:latin typeface="Open Sans"/>
+              </a:rPr>
+              <a:t>3  SELEÇÃO</a:t>
+            </a:r>
+          </a:p>
+        </p:txBody>
+      </p:sp>
+      <p:sp>
+        <p:nvSpPr>
+          <p:cNvPr id="25" name="TextBox 24"/>
+          <p:cNvSpPr txBox="1"/>
+          <p:nvPr/>
+        </p:nvSpPr>
+        <p:spPr>
+          <a:xfrm>
+            <a:off x="6574536" y="4375404"/>
+            <a:ext cx="4791456" cy="640080"/>
+          </a:xfrm>
+          <a:prstGeom prst="rect">
+            <a:avLst/>
+          </a:prstGeom>
+          <a:noFill/>
+        </p:spPr>
+        <p:txBody>
+          <a:bodyPr wrap="square" lIns="0" rIns="0" tIns="0" bIns="0" anchor="t">
+            <a:noAutofit/>
+          </a:bodyPr>
+          <a:lstStyle/>
+          <a:p>
+            <a:pPr algn="l">
+              <a:lnSpc>
+                <a:spcPct val="100000"/>
+              </a:lnSpc>
+              <a:spcBef>
+                <a:spcPts val="0"/>
+              </a:spcBef>
+              <a:spcAft>
+                <a:spcPts val="0"/>
+              </a:spcAft>
+            </a:pPr>
+            <a:r>
+              <a:rPr sz="1600" b="0" i="0">
+                <a:solidFill>
+                  <a:srgbClr val="17201B"/>
+                </a:solidFill>
+                <a:latin typeface="Open Sans"/>
+              </a:rPr>
+              <a:t>os 10% melhores passam direto</a:t>
+            </a:r>
+          </a:p>
+          <a:p>
+            <a:pPr algn="l">
+              <a:lnSpc>
+                <a:spcPct val="100000"/>
+              </a:lnSpc>
+              <a:spcBef>
+                <a:spcPts val="400"/>
+              </a:spcBef>
+              <a:spcAft>
+                <a:spcPts val="0"/>
+              </a:spcAft>
+            </a:pPr>
+            <a:r>
+              <a:rPr sz="1600" b="0" i="0">
+                <a:solidFill>
+                  <a:srgbClr val="17201B"/>
+                </a:solidFill>
+                <a:latin typeface="Open Sans"/>
+              </a:rPr>
+              <a:t>cada pai é o melhor de 3 sorteados</a:t>
+            </a:r>
+          </a:p>
+        </p:txBody>
+      </p:sp>
+      <p:sp>
+        <p:nvSpPr>
+          <p:cNvPr id="26" name="TextBox 25"/>
+          <p:cNvSpPr txBox="1"/>
+          <p:nvPr/>
+        </p:nvSpPr>
+        <p:spPr>
+          <a:xfrm>
+            <a:off x="6574536" y="5239512"/>
+            <a:ext cx="4791456" cy="265176"/>
+          </a:xfrm>
+          <a:prstGeom prst="rect">
+            <a:avLst/>
+          </a:prstGeom>
+          <a:noFill/>
+        </p:spPr>
+        <p:txBody>
+          <a:bodyPr wrap="square" lIns="0" rIns="0" tIns="0" bIns="0" anchor="t">
+            <a:noAutofit/>
+          </a:bodyPr>
+          <a:lstStyle/>
+          <a:p>
+            <a:pPr algn="l">
+              <a:lnSpc>
+                <a:spcPct val="100000"/>
+              </a:lnSpc>
+              <a:spcBef>
+                <a:spcPts val="0"/>
+              </a:spcBef>
+              <a:spcAft>
+                <a:spcPts val="0"/>
+              </a:spcAft>
+            </a:pPr>
+            <a:r>
+              <a:rPr sz="1500" b="1" i="0">
+                <a:solidFill>
+                  <a:srgbClr val="2A78D6"/>
+                </a:solidFill>
+                <a:latin typeface="Open Sans"/>
+              </a:rPr>
+              <a:t>AG escalar: a aptidão é a soma dos dois termos</a:t>
+            </a:r>
+          </a:p>
+        </p:txBody>
+      </p:sp>
+      <p:sp>
+        <p:nvSpPr>
+          <p:cNvPr id="27" name="TextBox 26"/>
+          <p:cNvSpPr txBox="1"/>
+          <p:nvPr/>
+        </p:nvSpPr>
+        <p:spPr>
+          <a:xfrm>
+            <a:off x="822959" y="4009644"/>
+            <a:ext cx="3657600" cy="310896"/>
+          </a:xfrm>
+          <a:prstGeom prst="rect">
+            <a:avLst/>
+          </a:prstGeom>
+          <a:noFill/>
+        </p:spPr>
+        <p:txBody>
+          <a:bodyPr wrap="square" lIns="0" rIns="0" tIns="0" bIns="0" anchor="t">
+            <a:noAutofit/>
+          </a:bodyPr>
+          <a:lstStyle/>
+          <a:p>
+            <a:pPr algn="l">
+              <a:lnSpc>
+                <a:spcPct val="100000"/>
+              </a:lnSpc>
+              <a:spcBef>
+                <a:spcPts val="0"/>
+              </a:spcBef>
+              <a:spcAft>
+                <a:spcPts val="0"/>
+              </a:spcAft>
+            </a:pPr>
+            <a:r>
+              <a:rPr sz="1500" b="1" i="0">
+                <a:solidFill>
+                  <a:srgbClr val="2F9E41"/>
+                </a:solidFill>
+                <a:latin typeface="Open Sans"/>
+              </a:rPr>
+              <a:t>4  VARIAÇÃO</a:t>
+            </a:r>
+          </a:p>
+        </p:txBody>
+      </p:sp>
+      <p:sp>
+        <p:nvSpPr>
+          <p:cNvPr id="28" name="TextBox 27"/>
+          <p:cNvSpPr txBox="1"/>
+          <p:nvPr/>
+        </p:nvSpPr>
+        <p:spPr>
+          <a:xfrm>
+            <a:off x="822959" y="4375404"/>
+            <a:ext cx="2377440" cy="292608"/>
+          </a:xfrm>
+          <a:prstGeom prst="rect">
+            <a:avLst/>
+          </a:prstGeom>
+          <a:noFill/>
+        </p:spPr>
+        <p:txBody>
+          <a:bodyPr wrap="square" lIns="0" rIns="0" tIns="0" bIns="0" anchor="t">
+            <a:noAutofit/>
+          </a:bodyPr>
+          <a:lstStyle/>
+          <a:p>
+            <a:pPr algn="l">
+              <a:lnSpc>
+                <a:spcPct val="100000"/>
+              </a:lnSpc>
+              <a:spcBef>
+                <a:spcPts val="0"/>
+              </a:spcBef>
+              <a:spcAft>
+                <a:spcPts val="0"/>
+              </a:spcAft>
+            </a:pPr>
+            <a:r>
+              <a:rPr sz="1600" b="1" i="0">
+                <a:solidFill>
+                  <a:srgbClr val="17201B"/>
+                </a:solidFill>
+                <a:latin typeface="Open Sans"/>
+              </a:rPr>
+              <a:t>cruzamento</a:t>
+            </a:r>
+          </a:p>
+        </p:txBody>
+      </p:sp>
+      <p:sp>
+        <p:nvSpPr>
+          <p:cNvPr id="29" name="TextBox 28"/>
+          <p:cNvSpPr txBox="1"/>
+          <p:nvPr/>
+        </p:nvSpPr>
+        <p:spPr>
+          <a:xfrm>
+            <a:off x="822959" y="4722876"/>
+            <a:ext cx="530352" cy="256032"/>
+          </a:xfrm>
+          <a:prstGeom prst="rect">
+            <a:avLst/>
+          </a:prstGeom>
+          <a:noFill/>
+        </p:spPr>
+        <p:txBody>
+          <a:bodyPr wrap="square" lIns="0" rIns="0" tIns="0" bIns="0" anchor="t">
+            <a:noAutofit/>
+          </a:bodyPr>
+          <a:lstStyle/>
+          <a:p>
+            <a:pPr algn="l">
+              <a:lnSpc>
+                <a:spcPct val="100000"/>
+              </a:lnSpc>
+              <a:spcBef>
+                <a:spcPts val="0"/>
+              </a:spcBef>
+              <a:spcAft>
+                <a:spcPts val="0"/>
+              </a:spcAft>
+            </a:pPr>
+            <a:r>
+              <a:rPr sz="1300" b="0" i="0">
+                <a:solidFill>
+                  <a:srgbClr val="4A524D"/>
+                </a:solidFill>
+                <a:latin typeface="Open Sans"/>
+              </a:rPr>
+              <a:t>pai A</a:t>
+            </a:r>
+          </a:p>
+        </p:txBody>
+      </p:sp>
+      <p:sp>
+        <p:nvSpPr>
+          <p:cNvPr id="30" name="Rounded Rectangle 29"/>
+          <p:cNvSpPr/>
+          <p:nvPr/>
+        </p:nvSpPr>
+        <p:spPr>
+          <a:xfrm>
+            <a:off x="1389888" y="4759452"/>
+            <a:ext cx="182880" cy="182880"/>
+          </a:xfrm>
+          <a:prstGeom prst="roundRect">
+            <a:avLst>
+              <a:gd name="adj" fmla="val 20000"/>
+            </a:avLst>
+          </a:prstGeom>
+          <a:solidFill>
+            <a:srgbClr val="4A524D"/>
+          </a:solidFill>
+          <a:ln>
+            <a:noFill/>
+          </a:ln>
+        </p:spPr>
+        <p:txBody>
+          <a:bodyPr rtlCol="0" anchor="ctr"/>
+          <a:lstStyle/>
+          <a:p>
+            <a:pPr algn="ctr"/>
+          </a:p>
+        </p:txBody>
+      </p:sp>
+      <p:sp>
+        <p:nvSpPr>
+          <p:cNvPr id="31" name="Rounded Rectangle 30"/>
+          <p:cNvSpPr/>
+          <p:nvPr/>
+        </p:nvSpPr>
+        <p:spPr>
+          <a:xfrm>
+            <a:off x="1618488" y="4759452"/>
+            <a:ext cx="182880" cy="182880"/>
+          </a:xfrm>
+          <a:prstGeom prst="roundRect">
+            <a:avLst>
+              <a:gd name="adj" fmla="val 20000"/>
+            </a:avLst>
+          </a:prstGeom>
+          <a:solidFill>
+            <a:srgbClr val="4A524D"/>
+          </a:solidFill>
+          <a:ln>
+            <a:noFill/>
+          </a:ln>
+        </p:spPr>
+        <p:txBody>
+          <a:bodyPr rtlCol="0" anchor="ctr"/>
+          <a:lstStyle/>
+          <a:p>
+            <a:pPr algn="ctr"/>
+          </a:p>
+        </p:txBody>
+      </p:sp>
+      <p:sp>
+        <p:nvSpPr>
+          <p:cNvPr id="32" name="Rounded Rectangle 31"/>
+          <p:cNvSpPr/>
+          <p:nvPr/>
+        </p:nvSpPr>
+        <p:spPr>
+          <a:xfrm>
+            <a:off x="1847088" y="4759452"/>
+            <a:ext cx="182880" cy="182880"/>
+          </a:xfrm>
+          <a:prstGeom prst="roundRect">
+            <a:avLst>
+              <a:gd name="adj" fmla="val 20000"/>
+            </a:avLst>
+          </a:prstGeom>
+          <a:solidFill>
+            <a:srgbClr val="4A524D"/>
+          </a:solidFill>
+          <a:ln>
+            <a:noFill/>
+          </a:ln>
+        </p:spPr>
+        <p:txBody>
+          <a:bodyPr rtlCol="0" anchor="ctr"/>
+          <a:lstStyle/>
+          <a:p>
+            <a:pPr algn="ctr"/>
+          </a:p>
+        </p:txBody>
+      </p:sp>
+      <p:sp>
+        <p:nvSpPr>
+          <p:cNvPr id="33" name="Rounded Rectangle 32"/>
+          <p:cNvSpPr/>
+          <p:nvPr/>
+        </p:nvSpPr>
+        <p:spPr>
+          <a:xfrm>
+            <a:off x="2075688" y="4759452"/>
+            <a:ext cx="182880" cy="182880"/>
+          </a:xfrm>
+          <a:prstGeom prst="roundRect">
+            <a:avLst>
+              <a:gd name="adj" fmla="val 20000"/>
+            </a:avLst>
+          </a:prstGeom>
+          <a:solidFill>
+            <a:srgbClr val="4A524D"/>
+          </a:solidFill>
+          <a:ln>
+            <a:noFill/>
+          </a:ln>
+        </p:spPr>
+        <p:txBody>
+          <a:bodyPr rtlCol="0" anchor="ctr"/>
+          <a:lstStyle/>
+          <a:p>
+            <a:pPr algn="ctr"/>
+          </a:p>
+        </p:txBody>
+      </p:sp>
+      <p:sp>
+        <p:nvSpPr>
+          <p:cNvPr id="34" name="Rounded Rectangle 33"/>
+          <p:cNvSpPr/>
+          <p:nvPr/>
+        </p:nvSpPr>
+        <p:spPr>
+          <a:xfrm>
+            <a:off x="2304288" y="4759452"/>
+            <a:ext cx="182880" cy="182880"/>
+          </a:xfrm>
+          <a:prstGeom prst="roundRect">
+            <a:avLst>
+              <a:gd name="adj" fmla="val 20000"/>
+            </a:avLst>
+          </a:prstGeom>
+          <a:solidFill>
+            <a:srgbClr val="4A524D"/>
+          </a:solidFill>
+          <a:ln>
+            <a:noFill/>
+          </a:ln>
+        </p:spPr>
+        <p:txBody>
+          <a:bodyPr rtlCol="0" anchor="ctr"/>
+          <a:lstStyle/>
+          <a:p>
+            <a:pPr algn="ctr"/>
+          </a:p>
+        </p:txBody>
+      </p:sp>
+      <p:sp>
+        <p:nvSpPr>
+          <p:cNvPr id="35" name="TextBox 34"/>
+          <p:cNvSpPr txBox="1"/>
+          <p:nvPr/>
+        </p:nvSpPr>
+        <p:spPr>
+          <a:xfrm>
+            <a:off x="822959" y="4988052"/>
+            <a:ext cx="530352" cy="256032"/>
+          </a:xfrm>
+          <a:prstGeom prst="rect">
+            <a:avLst/>
+          </a:prstGeom>
+          <a:noFill/>
+        </p:spPr>
+        <p:txBody>
+          <a:bodyPr wrap="square" lIns="0" rIns="0" tIns="0" bIns="0" anchor="t">
+            <a:noAutofit/>
+          </a:bodyPr>
+          <a:lstStyle/>
+          <a:p>
+            <a:pPr algn="l">
+              <a:lnSpc>
+                <a:spcPct val="100000"/>
+              </a:lnSpc>
+              <a:spcBef>
+                <a:spcPts val="0"/>
+              </a:spcBef>
+              <a:spcAft>
+                <a:spcPts val="0"/>
+              </a:spcAft>
+            </a:pPr>
+            <a:r>
+              <a:rPr sz="1300" b="0" i="0">
+                <a:solidFill>
+                  <a:srgbClr val="4A524D"/>
+                </a:solidFill>
+                <a:latin typeface="Open Sans"/>
+              </a:rPr>
+              <a:t>pai B</a:t>
+            </a:r>
+          </a:p>
+        </p:txBody>
+      </p:sp>
+      <p:sp>
+        <p:nvSpPr>
+          <p:cNvPr id="36" name="Rounded Rectangle 35"/>
+          <p:cNvSpPr/>
+          <p:nvPr/>
+        </p:nvSpPr>
+        <p:spPr>
+          <a:xfrm>
+            <a:off x="1389888" y="5024628"/>
+            <a:ext cx="182880" cy="182880"/>
+          </a:xfrm>
+          <a:prstGeom prst="roundRect">
+            <a:avLst>
+              <a:gd name="adj" fmla="val 20000"/>
+            </a:avLst>
+          </a:prstGeom>
+          <a:solidFill>
+            <a:srgbClr val="AEB4B0"/>
+          </a:solidFill>
+          <a:ln>
+            <a:noFill/>
+          </a:ln>
+        </p:spPr>
+        <p:txBody>
+          <a:bodyPr rtlCol="0" anchor="ctr"/>
+          <a:lstStyle/>
+          <a:p>
+            <a:pPr algn="ctr"/>
+          </a:p>
+        </p:txBody>
+      </p:sp>
+      <p:sp>
+        <p:nvSpPr>
+          <p:cNvPr id="37" name="Rounded Rectangle 36"/>
+          <p:cNvSpPr/>
+          <p:nvPr/>
+        </p:nvSpPr>
+        <p:spPr>
+          <a:xfrm>
+            <a:off x="1618488" y="5024628"/>
+            <a:ext cx="182880" cy="182880"/>
+          </a:xfrm>
+          <a:prstGeom prst="roundRect">
+            <a:avLst>
+              <a:gd name="adj" fmla="val 20000"/>
+            </a:avLst>
+          </a:prstGeom>
+          <a:solidFill>
+            <a:srgbClr val="AEB4B0"/>
+          </a:solidFill>
+          <a:ln>
+            <a:noFill/>
+          </a:ln>
+        </p:spPr>
+        <p:txBody>
+          <a:bodyPr rtlCol="0" anchor="ctr"/>
+          <a:lstStyle/>
+          <a:p>
+            <a:pPr algn="ctr"/>
+          </a:p>
+        </p:txBody>
+      </p:sp>
+      <p:sp>
+        <p:nvSpPr>
+          <p:cNvPr id="38" name="Rounded Rectangle 37"/>
+          <p:cNvSpPr/>
+          <p:nvPr/>
+        </p:nvSpPr>
+        <p:spPr>
+          <a:xfrm>
+            <a:off x="1847088" y="5024628"/>
+            <a:ext cx="182880" cy="182880"/>
+          </a:xfrm>
+          <a:prstGeom prst="roundRect">
+            <a:avLst>
+              <a:gd name="adj" fmla="val 20000"/>
+            </a:avLst>
+          </a:prstGeom>
+          <a:solidFill>
+            <a:srgbClr val="AEB4B0"/>
+          </a:solidFill>
+          <a:ln>
+            <a:noFill/>
+          </a:ln>
+        </p:spPr>
+        <p:txBody>
+          <a:bodyPr rtlCol="0" anchor="ctr"/>
+          <a:lstStyle/>
+          <a:p>
+            <a:pPr algn="ctr"/>
+          </a:p>
+        </p:txBody>
+      </p:sp>
+      <p:sp>
+        <p:nvSpPr>
+          <p:cNvPr id="39" name="Rounded Rectangle 38"/>
+          <p:cNvSpPr/>
+          <p:nvPr/>
+        </p:nvSpPr>
+        <p:spPr>
+          <a:xfrm>
+            <a:off x="2075688" y="5024628"/>
+            <a:ext cx="182880" cy="182880"/>
+          </a:xfrm>
+          <a:prstGeom prst="roundRect">
+            <a:avLst>
+              <a:gd name="adj" fmla="val 20000"/>
+            </a:avLst>
+          </a:prstGeom>
+          <a:solidFill>
+            <a:srgbClr val="AEB4B0"/>
+          </a:solidFill>
+          <a:ln>
+            <a:noFill/>
+          </a:ln>
+        </p:spPr>
+        <p:txBody>
+          <a:bodyPr rtlCol="0" anchor="ctr"/>
+          <a:lstStyle/>
+          <a:p>
+            <a:pPr algn="ctr"/>
+          </a:p>
+        </p:txBody>
+      </p:sp>
+      <p:sp>
+        <p:nvSpPr>
+          <p:cNvPr id="40" name="Rounded Rectangle 39"/>
+          <p:cNvSpPr/>
+          <p:nvPr/>
+        </p:nvSpPr>
+        <p:spPr>
+          <a:xfrm>
+            <a:off x="2304288" y="5024628"/>
+            <a:ext cx="182880" cy="182880"/>
+          </a:xfrm>
+          <a:prstGeom prst="roundRect">
+            <a:avLst>
+              <a:gd name="adj" fmla="val 20000"/>
+            </a:avLst>
+          </a:prstGeom>
+          <a:solidFill>
+            <a:srgbClr val="AEB4B0"/>
+          </a:solidFill>
+          <a:ln>
+            <a:noFill/>
+          </a:ln>
+        </p:spPr>
+        <p:txBody>
+          <a:bodyPr rtlCol="0" anchor="ctr"/>
+          <a:lstStyle/>
+          <a:p>
+            <a:pPr algn="ctr"/>
+          </a:p>
+        </p:txBody>
+      </p:sp>
+      <p:sp>
+        <p:nvSpPr>
+          <p:cNvPr id="41" name="TextBox 40"/>
+          <p:cNvSpPr txBox="1"/>
+          <p:nvPr/>
+        </p:nvSpPr>
+        <p:spPr>
+          <a:xfrm>
+            <a:off x="822959" y="5298948"/>
+            <a:ext cx="530352" cy="256032"/>
+          </a:xfrm>
+          <a:prstGeom prst="rect">
+            <a:avLst/>
+          </a:prstGeom>
+          <a:noFill/>
+        </p:spPr>
+        <p:txBody>
+          <a:bodyPr wrap="square" lIns="0" rIns="0" tIns="0" bIns="0" anchor="t">
+            <a:noAutofit/>
+          </a:bodyPr>
+          <a:lstStyle/>
+          <a:p>
+            <a:pPr algn="l">
+              <a:lnSpc>
+                <a:spcPct val="100000"/>
+              </a:lnSpc>
+              <a:spcBef>
+                <a:spcPts val="0"/>
+              </a:spcBef>
+              <a:spcAft>
+                <a:spcPts val="0"/>
+              </a:spcAft>
+            </a:pPr>
+            <a:r>
+              <a:rPr sz="1300" b="1" i="0">
+                <a:solidFill>
+                  <a:srgbClr val="4A524D"/>
+                </a:solidFill>
+                <a:latin typeface="Open Sans"/>
+              </a:rPr>
+              <a:t>filho</a:t>
+            </a:r>
+          </a:p>
+        </p:txBody>
+      </p:sp>
+      <p:sp>
+        <p:nvSpPr>
+          <p:cNvPr id="42" name="Rounded Rectangle 41"/>
+          <p:cNvSpPr/>
+          <p:nvPr/>
+        </p:nvSpPr>
+        <p:spPr>
+          <a:xfrm>
+            <a:off x="1389888" y="5335524"/>
+            <a:ext cx="182880" cy="182880"/>
+          </a:xfrm>
+          <a:prstGeom prst="roundRect">
+            <a:avLst>
+              <a:gd name="adj" fmla="val 20000"/>
+            </a:avLst>
+          </a:prstGeom>
+          <a:solidFill>
+            <a:srgbClr val="4A524D"/>
+          </a:solidFill>
+          <a:ln>
+            <a:noFill/>
+          </a:ln>
+        </p:spPr>
+        <p:txBody>
+          <a:bodyPr rtlCol="0" anchor="ctr"/>
+          <a:lstStyle/>
+          <a:p>
+            <a:pPr algn="ctr"/>
+          </a:p>
+        </p:txBody>
+      </p:sp>
+      <p:sp>
+        <p:nvSpPr>
+          <p:cNvPr id="43" name="Rounded Rectangle 42"/>
+          <p:cNvSpPr/>
+          <p:nvPr/>
+        </p:nvSpPr>
+        <p:spPr>
+          <a:xfrm>
+            <a:off x="1618488" y="5335524"/>
+            <a:ext cx="182880" cy="182880"/>
+          </a:xfrm>
+          <a:prstGeom prst="roundRect">
+            <a:avLst>
+              <a:gd name="adj" fmla="val 20000"/>
+            </a:avLst>
+          </a:prstGeom>
+          <a:solidFill>
+            <a:srgbClr val="AEB4B0"/>
+          </a:solidFill>
+          <a:ln>
+            <a:noFill/>
+          </a:ln>
+        </p:spPr>
+        <p:txBody>
+          <a:bodyPr rtlCol="0" anchor="ctr"/>
+          <a:lstStyle/>
+          <a:p>
+            <a:pPr algn="ctr"/>
+          </a:p>
+        </p:txBody>
+      </p:sp>
+      <p:sp>
+        <p:nvSpPr>
+          <p:cNvPr id="44" name="Rounded Rectangle 43"/>
+          <p:cNvSpPr/>
+          <p:nvPr/>
+        </p:nvSpPr>
+        <p:spPr>
+          <a:xfrm>
+            <a:off x="1847088" y="5335524"/>
+            <a:ext cx="182880" cy="182880"/>
+          </a:xfrm>
+          <a:prstGeom prst="roundRect">
+            <a:avLst>
+              <a:gd name="adj" fmla="val 20000"/>
+            </a:avLst>
+          </a:prstGeom>
+          <a:solidFill>
+            <a:srgbClr val="4A524D"/>
+          </a:solidFill>
+          <a:ln>
+            <a:noFill/>
+          </a:ln>
+        </p:spPr>
+        <p:txBody>
+          <a:bodyPr rtlCol="0" anchor="ctr"/>
+          <a:lstStyle/>
+          <a:p>
+            <a:pPr algn="ctr"/>
+          </a:p>
+        </p:txBody>
+      </p:sp>
+      <p:sp>
+        <p:nvSpPr>
+          <p:cNvPr id="45" name="Rounded Rectangle 44"/>
+          <p:cNvSpPr/>
+          <p:nvPr/>
+        </p:nvSpPr>
+        <p:spPr>
+          <a:xfrm>
+            <a:off x="2075688" y="5335524"/>
+            <a:ext cx="182880" cy="182880"/>
+          </a:xfrm>
+          <a:prstGeom prst="roundRect">
+            <a:avLst>
+              <a:gd name="adj" fmla="val 20000"/>
+            </a:avLst>
+          </a:prstGeom>
+          <a:solidFill>
+            <a:srgbClr val="4A524D"/>
+          </a:solidFill>
+          <a:ln>
+            <a:noFill/>
+          </a:ln>
+        </p:spPr>
+        <p:txBody>
+          <a:bodyPr rtlCol="0" anchor="ctr"/>
+          <a:lstStyle/>
+          <a:p>
+            <a:pPr algn="ctr"/>
+          </a:p>
+        </p:txBody>
+      </p:sp>
+      <p:sp>
+        <p:nvSpPr>
+          <p:cNvPr id="46" name="Rounded Rectangle 45"/>
+          <p:cNvSpPr/>
+          <p:nvPr/>
+        </p:nvSpPr>
+        <p:spPr>
+          <a:xfrm>
+            <a:off x="2304288" y="5335524"/>
+            <a:ext cx="182880" cy="182880"/>
+          </a:xfrm>
+          <a:prstGeom prst="roundRect">
+            <a:avLst>
+              <a:gd name="adj" fmla="val 20000"/>
+            </a:avLst>
+          </a:prstGeom>
+          <a:solidFill>
+            <a:srgbClr val="AEB4B0"/>
+          </a:solidFill>
+          <a:ln>
+            <a:noFill/>
+          </a:ln>
+        </p:spPr>
+        <p:txBody>
+          <a:bodyPr rtlCol="0" anchor="ctr"/>
+          <a:lstStyle/>
+          <a:p>
+            <a:pPr algn="ctr"/>
+          </a:p>
+        </p:txBody>
+      </p:sp>
+      <p:sp>
+        <p:nvSpPr>
+          <p:cNvPr id="47" name="TextBox 46"/>
+          <p:cNvSpPr txBox="1"/>
+          <p:nvPr/>
+        </p:nvSpPr>
+        <p:spPr>
+          <a:xfrm>
+            <a:off x="3429000" y="4375404"/>
+            <a:ext cx="2185416" cy="292608"/>
+          </a:xfrm>
+          <a:prstGeom prst="rect">
+            <a:avLst/>
+          </a:prstGeom>
+          <a:noFill/>
+        </p:spPr>
+        <p:txBody>
+          <a:bodyPr wrap="square" lIns="0" rIns="0" tIns="0" bIns="0" anchor="t">
+            <a:noAutofit/>
+          </a:bodyPr>
+          <a:lstStyle/>
+          <a:p>
+            <a:pPr algn="l">
+              <a:lnSpc>
+                <a:spcPct val="100000"/>
+              </a:lnSpc>
+              <a:spcBef>
+                <a:spcPts val="0"/>
+              </a:spcBef>
+              <a:spcAft>
+                <a:spcPts val="0"/>
+              </a:spcAft>
+            </a:pPr>
+            <a:r>
+              <a:rPr sz="1600" b="1" i="0">
+                <a:solidFill>
+                  <a:srgbClr val="17201B"/>
+                </a:solidFill>
+                <a:latin typeface="Open Sans"/>
+              </a:rPr>
+              <a:t>mutação</a:t>
+            </a:r>
+          </a:p>
+        </p:txBody>
+      </p:sp>
+      <p:sp>
+        <p:nvSpPr>
+          <p:cNvPr id="48" name="TextBox 47"/>
+          <p:cNvSpPr txBox="1"/>
+          <p:nvPr/>
+        </p:nvSpPr>
+        <p:spPr>
+          <a:xfrm>
+            <a:off x="3429000" y="4695444"/>
+            <a:ext cx="2185416" cy="548640"/>
+          </a:xfrm>
+          <a:prstGeom prst="rect">
+            <a:avLst/>
+          </a:prstGeom>
+          <a:noFill/>
+        </p:spPr>
+        <p:txBody>
+          <a:bodyPr wrap="square" lIns="0" rIns="0" tIns="0" bIns="0" anchor="t">
+            <a:noAutofit/>
+          </a:bodyPr>
+          <a:lstStyle/>
+          <a:p>
+            <a:pPr algn="l">
+              <a:lnSpc>
+                <a:spcPct val="100000"/>
+              </a:lnSpc>
+              <a:spcBef>
+                <a:spcPts val="0"/>
+              </a:spcBef>
+              <a:spcAft>
+                <a:spcPts val="0"/>
+              </a:spcAft>
+            </a:pPr>
+            <a:r>
+              <a:rPr sz="1500" b="0" i="0">
+                <a:solidFill>
+                  <a:srgbClr val="17201B"/>
+                </a:solidFill>
+                <a:latin typeface="Open Sans"/>
+              </a:rPr>
+              <a:t>ruído gaussiano em 5% dos genes</a:t>
+            </a:r>
+          </a:p>
+        </p:txBody>
+      </p:sp>
+      <p:sp>
+        <p:nvSpPr>
+          <p:cNvPr id="49" name="TextBox 48"/>
+          <p:cNvSpPr txBox="1"/>
+          <p:nvPr/>
+        </p:nvSpPr>
+        <p:spPr>
+          <a:xfrm>
+            <a:off x="3429000" y="5239512"/>
+            <a:ext cx="2185416" cy="265176"/>
+          </a:xfrm>
+          <a:prstGeom prst="rect">
+            <a:avLst/>
+          </a:prstGeom>
+          <a:noFill/>
+        </p:spPr>
+        <p:txBody>
+          <a:bodyPr wrap="square" lIns="0" rIns="0" tIns="0" bIns="0" anchor="t">
+            <a:noAutofit/>
+          </a:bodyPr>
+          <a:lstStyle/>
+          <a:p>
+            <a:pPr algn="l">
+              <a:lnSpc>
+                <a:spcPct val="100000"/>
+              </a:lnSpc>
+              <a:spcBef>
+                <a:spcPts val="0"/>
+              </a:spcBef>
+              <a:spcAft>
+                <a:spcPts val="0"/>
+              </a:spcAft>
+            </a:pPr>
+            <a:r>
+              <a:rPr sz="1500" b="1" i="0">
+                <a:solidFill>
+                  <a:srgbClr val="17201B"/>
+                </a:solidFill>
+                <a:latin typeface="Open Sans"/>
+              </a:rPr>
+              <a:t>pesos: passo 4× menor</a:t>
+            </a:r>
+          </a:p>
+        </p:txBody>
+      </p:sp>
+      <p:sp>
+        <p:nvSpPr>
+          <p:cNvPr id="50" name="TextBox 49"/>
+          <p:cNvSpPr txBox="1"/>
+          <p:nvPr/>
+        </p:nvSpPr>
+        <p:spPr>
+          <a:xfrm>
+            <a:off x="548640" y="5852160"/>
+            <a:ext cx="11091672" cy="347472"/>
+          </a:xfrm>
+          <a:prstGeom prst="rect">
+            <a:avLst/>
+          </a:prstGeom>
+          <a:noFill/>
+        </p:spPr>
+        <p:txBody>
+          <a:bodyPr wrap="square" lIns="0" rIns="0" tIns="0" bIns="0" anchor="t">
+            <a:noAutofit/>
+          </a:bodyPr>
+          <a:lstStyle/>
+          <a:p>
+            <a:pPr algn="l">
+              <a:lnSpc>
+                <a:spcPct val="100000"/>
+              </a:lnSpc>
+              <a:spcBef>
+                <a:spcPts val="0"/>
+              </a:spcBef>
+              <a:spcAft>
+                <a:spcPts val="0"/>
+              </a:spcAft>
+            </a:pPr>
+            <a:r>
+              <a:rPr sz="1500" b="0" i="0">
+                <a:solidFill>
+                  <a:srgbClr val="6F7772"/>
+                </a:solidFill>
+                <a:latin typeface="Open Sans"/>
+              </a:rPr>
+              <a:t>Saída: o melhor elenco da última geração. O NSGA-II usa o mesmo ciclo, com outra seleção.</a:t>
+            </a:r>
+          </a:p>
+        </p:txBody>
+      </p:sp>
+    </p:spTree>
+  </p:cSld>
+  <p:clrMapOvr>
+    <a:masterClrMapping/>
+  </p:clrMapOvr>
+</p:sld>
+</file>
+
 <file path=ppt/slides/slide4.xml><?xml version="1.0" encoding="utf-8"?>
 <p:sld xmlns:a="http://schemas.openxmlformats.org/drawingml/2006/main" xmlns:p="http://schemas.openxmlformats.org/presentationml/2006/main" xmlns:r="http://schemas.openxmlformats.org/officeDocument/2006/relationships">
   <p:cSld>
@@ -38044,7 +40098,7 @@
                 </a:solidFill>
                 <a:latin typeface="Open Sans"/>
               </a:rPr>
-              <a:t>Três algoritmos, um só orçamento e um controle sem identidade</a:t>
+              <a:t>O NSGA-II não soma os termos: devolve uma fronteira</a:t>
             </a:r>
           </a:p>
         </p:txBody>
@@ -38089,7 +40143,7 @@
                 </a:solidFill>
                 <a:latin typeface="Open Sans"/>
               </a:rPr>
-              <a:t>6</a:t>
+              <a:t>7</a:t>
             </a:r>
           </a:p>
         </p:txBody>
@@ -38103,11 +40157,1004 @@
         <p:spPr>
           <a:xfrm>
             <a:off x="548640" y="1709928"/>
-            <a:ext cx="2651760" cy="2377440"/>
+            <a:ext cx="6035040" cy="3931920"/>
           </a:xfrm>
           <a:prstGeom prst="roundRect">
             <a:avLst>
-              <a:gd name="adj" fmla="val 4615"/>
+              <a:gd name="adj" fmla="val 2790"/>
+            </a:avLst>
+          </a:prstGeom>
+          <a:solidFill>
+            <a:srgbClr val="F2F4F3"/>
+          </a:solidFill>
+          <a:ln>
+            <a:noFill/>
+          </a:ln>
+        </p:spPr>
+        <p:txBody>
+          <a:bodyPr rtlCol="0" anchor="ctr"/>
+          <a:lstStyle/>
+          <a:p>
+            <a:pPr algn="ctr"/>
+          </a:p>
+        </p:txBody>
+      </p:sp>
+      <p:sp>
+        <p:nvSpPr>
+          <p:cNvPr id="8" name="TextBox 7"/>
+          <p:cNvSpPr txBox="1"/>
+          <p:nvPr/>
+        </p:nvSpPr>
+        <p:spPr>
+          <a:xfrm>
+            <a:off x="868680" y="1847088"/>
+            <a:ext cx="4572000" cy="310896"/>
+          </a:xfrm>
+          <a:prstGeom prst="rect">
+            <a:avLst/>
+          </a:prstGeom>
+          <a:noFill/>
+        </p:spPr>
+        <p:txBody>
+          <a:bodyPr wrap="square" lIns="0" rIns="0" tIns="0" bIns="0" anchor="t">
+            <a:noAutofit/>
+          </a:bodyPr>
+          <a:lstStyle/>
+          <a:p>
+            <a:pPr algn="l">
+              <a:lnSpc>
+                <a:spcPct val="100000"/>
+              </a:lnSpc>
+              <a:spcBef>
+                <a:spcPts val="0"/>
+              </a:spcBef>
+              <a:spcAft>
+                <a:spcPts val="0"/>
+              </a:spcAft>
+            </a:pPr>
+            <a:r>
+              <a:rPr sz="1500" b="1" i="0">
+                <a:solidFill>
+                  <a:srgbClr val="EB6834"/>
+                </a:solidFill>
+                <a:latin typeface="Open Sans"/>
+              </a:rPr>
+              <a:t>DOMINÂNCIA DE PARETO</a:t>
+            </a:r>
+          </a:p>
+        </p:txBody>
+      </p:sp>
+      <p:cxnSp>
+        <p:nvCxnSpPr>
+          <p:cNvPr id="9" name="Connector 8"/>
+          <p:cNvCxnSpPr/>
+          <p:nvPr/>
+        </p:nvCxnSpPr>
+        <p:spPr>
+          <a:xfrm>
+            <a:off x="1325880" y="4498848"/>
+            <a:ext cx="4846320" cy="0"/>
+          </a:xfrm>
+          <a:prstGeom prst="line">
+            <a:avLst/>
+          </a:prstGeom>
+          <a:ln w="19050">
+            <a:solidFill>
+              <a:srgbClr val="6F7772"/>
+            </a:solidFill>
+            <a:tailEnd type="triangle" w="med" len="med"/>
+          </a:ln>
+        </p:spPr>
+      </p:cxnSp>
+      <p:cxnSp>
+        <p:nvCxnSpPr>
+          <p:cNvPr id="10" name="Connector 9"/>
+          <p:cNvCxnSpPr/>
+          <p:nvPr/>
+        </p:nvCxnSpPr>
+        <p:spPr>
+          <a:xfrm flipV="1">
+            <a:off x="1325880" y="2350008"/>
+            <a:ext cx="0" cy="2148840"/>
+          </a:xfrm>
+          <a:prstGeom prst="line">
+            <a:avLst/>
+          </a:prstGeom>
+          <a:ln w="19050">
+            <a:solidFill>
+              <a:srgbClr val="6F7772"/>
+            </a:solidFill>
+            <a:tailEnd type="triangle" w="med" len="med"/>
+          </a:ln>
+        </p:spPr>
+      </p:cxnSp>
+      <p:sp>
+        <p:nvSpPr>
+          <p:cNvPr id="11" name="TextBox 10"/>
+          <p:cNvSpPr txBox="1"/>
+          <p:nvPr/>
+        </p:nvSpPr>
+        <p:spPr>
+          <a:xfrm>
+            <a:off x="3794760" y="4572000"/>
+            <a:ext cx="2377440" cy="274320"/>
+          </a:xfrm>
+          <a:prstGeom prst="rect">
+            <a:avLst/>
+          </a:prstGeom>
+          <a:noFill/>
+        </p:spPr>
+        <p:txBody>
+          <a:bodyPr wrap="square" lIns="0" rIns="0" tIns="0" bIns="0" anchor="t">
+            <a:noAutofit/>
+          </a:bodyPr>
+          <a:lstStyle/>
+          <a:p>
+            <a:pPr algn="r">
+              <a:lnSpc>
+                <a:spcPct val="100000"/>
+              </a:lnSpc>
+              <a:spcBef>
+                <a:spcPts val="0"/>
+              </a:spcBef>
+              <a:spcAft>
+                <a:spcPts val="0"/>
+              </a:spcAft>
+            </a:pPr>
+            <a:r>
+              <a:rPr sz="1400" b="0" i="0">
+                <a:solidFill>
+                  <a:srgbClr val="6F7772"/>
+                </a:solidFill>
+                <a:latin typeface="Open Sans"/>
+              </a:rPr>
+              <a:t>desequilíbrio</a:t>
+            </a:r>
+          </a:p>
+        </p:txBody>
+      </p:sp>
+      <p:sp>
+        <p:nvSpPr>
+          <p:cNvPr id="12" name="TextBox 11"/>
+          <p:cNvSpPr txBox="1"/>
+          <p:nvPr/>
+        </p:nvSpPr>
+        <p:spPr>
+          <a:xfrm>
+            <a:off x="1435607" y="2240280"/>
+            <a:ext cx="1828800" cy="274320"/>
+          </a:xfrm>
+          <a:prstGeom prst="rect">
+            <a:avLst/>
+          </a:prstGeom>
+          <a:noFill/>
+        </p:spPr>
+        <p:txBody>
+          <a:bodyPr wrap="square" lIns="0" rIns="0" tIns="0" bIns="0" anchor="t">
+            <a:noAutofit/>
+          </a:bodyPr>
+          <a:lstStyle/>
+          <a:p>
+            <a:pPr algn="l">
+              <a:lnSpc>
+                <a:spcPct val="100000"/>
+              </a:lnSpc>
+              <a:spcBef>
+                <a:spcPts val="0"/>
+              </a:spcBef>
+              <a:spcAft>
+                <a:spcPts val="0"/>
+              </a:spcAft>
+            </a:pPr>
+            <a:r>
+              <a:rPr sz="1400" b="0" i="0">
+                <a:solidFill>
+                  <a:srgbClr val="6F7772"/>
+                </a:solidFill>
+                <a:latin typeface="Open Sans"/>
+              </a:rPr>
+              <a:t>desvio</a:t>
+            </a:r>
+          </a:p>
+        </p:txBody>
+      </p:sp>
+      <p:sp>
+        <p:nvSpPr>
+          <p:cNvPr id="13" name="TextBox 12"/>
+          <p:cNvSpPr txBox="1"/>
+          <p:nvPr/>
+        </p:nvSpPr>
+        <p:spPr>
+          <a:xfrm>
+            <a:off x="914400" y="4572000"/>
+            <a:ext cx="822960" cy="256032"/>
+          </a:xfrm>
+          <a:prstGeom prst="rect">
+            <a:avLst/>
+          </a:prstGeom>
+          <a:noFill/>
+        </p:spPr>
+        <p:txBody>
+          <a:bodyPr wrap="square" lIns="0" rIns="0" tIns="0" bIns="0" anchor="t">
+            <a:noAutofit/>
+          </a:bodyPr>
+          <a:lstStyle/>
+          <a:p>
+            <a:pPr algn="ctr">
+              <a:lnSpc>
+                <a:spcPct val="100000"/>
+              </a:lnSpc>
+              <a:spcBef>
+                <a:spcPts val="0"/>
+              </a:spcBef>
+              <a:spcAft>
+                <a:spcPts val="0"/>
+              </a:spcAft>
+            </a:pPr>
+            <a:r>
+              <a:rPr sz="1300" b="1" i="0">
+                <a:solidFill>
+                  <a:srgbClr val="6F7772"/>
+                </a:solidFill>
+                <a:latin typeface="Open Sans"/>
+              </a:rPr>
+              <a:t>melhor</a:t>
+            </a:r>
+          </a:p>
+        </p:txBody>
+      </p:sp>
+      <p:sp>
+        <p:nvSpPr>
+          <p:cNvPr id="14" name="Rectangle 13"/>
+          <p:cNvSpPr/>
+          <p:nvPr/>
+        </p:nvSpPr>
+        <p:spPr>
+          <a:xfrm>
+            <a:off x="2793491" y="2560320"/>
+            <a:ext cx="3104387" cy="822959"/>
+          </a:xfrm>
+          <a:prstGeom prst="rect">
+            <a:avLst/>
+          </a:prstGeom>
+          <a:solidFill>
+            <a:srgbClr val="FDEEE7"/>
+          </a:solidFill>
+          <a:ln>
+            <a:noFill/>
+          </a:ln>
+        </p:spPr>
+        <p:txBody>
+          <a:bodyPr rtlCol="0" anchor="ctr"/>
+          <a:lstStyle/>
+          <a:p>
+            <a:pPr algn="ctr"/>
+          </a:p>
+        </p:txBody>
+      </p:sp>
+      <p:cxnSp>
+        <p:nvCxnSpPr>
+          <p:cNvPr id="15" name="Connector 14"/>
+          <p:cNvCxnSpPr/>
+          <p:nvPr/>
+        </p:nvCxnSpPr>
+        <p:spPr>
+          <a:xfrm>
+            <a:off x="1684781" y="2651760"/>
+            <a:ext cx="487833" cy="420624"/>
+          </a:xfrm>
+          <a:prstGeom prst="line">
+            <a:avLst/>
+          </a:prstGeom>
+          <a:ln w="31750">
+            <a:solidFill>
+              <a:srgbClr val="EB6834"/>
+            </a:solidFill>
+          </a:ln>
+        </p:spPr>
+      </p:cxnSp>
+      <p:cxnSp>
+        <p:nvCxnSpPr>
+          <p:cNvPr id="16" name="Connector 15"/>
+          <p:cNvCxnSpPr/>
+          <p:nvPr/>
+        </p:nvCxnSpPr>
+        <p:spPr>
+          <a:xfrm>
+            <a:off x="2172614" y="3072384"/>
+            <a:ext cx="620877" cy="310896"/>
+          </a:xfrm>
+          <a:prstGeom prst="line">
+            <a:avLst/>
+          </a:prstGeom>
+          <a:ln w="31750">
+            <a:solidFill>
+              <a:srgbClr val="EB6834"/>
+            </a:solidFill>
+          </a:ln>
+        </p:spPr>
+      </p:cxnSp>
+      <p:cxnSp>
+        <p:nvCxnSpPr>
+          <p:cNvPr id="17" name="Connector 16"/>
+          <p:cNvCxnSpPr/>
+          <p:nvPr/>
+        </p:nvCxnSpPr>
+        <p:spPr>
+          <a:xfrm>
+            <a:off x="2793491" y="3383280"/>
+            <a:ext cx="798272" cy="237744"/>
+          </a:xfrm>
+          <a:prstGeom prst="line">
+            <a:avLst/>
+          </a:prstGeom>
+          <a:ln w="31750">
+            <a:solidFill>
+              <a:srgbClr val="EB6834"/>
+            </a:solidFill>
+          </a:ln>
+        </p:spPr>
+      </p:cxnSp>
+      <p:cxnSp>
+        <p:nvCxnSpPr>
+          <p:cNvPr id="18" name="Connector 17"/>
+          <p:cNvCxnSpPr/>
+          <p:nvPr/>
+        </p:nvCxnSpPr>
+        <p:spPr>
+          <a:xfrm>
+            <a:off x="3591763" y="3621024"/>
+            <a:ext cx="975664" cy="164591"/>
+          </a:xfrm>
+          <a:prstGeom prst="line">
+            <a:avLst/>
+          </a:prstGeom>
+          <a:ln w="31750">
+            <a:solidFill>
+              <a:srgbClr val="EB6834"/>
+            </a:solidFill>
+          </a:ln>
+        </p:spPr>
+      </p:cxnSp>
+      <p:cxnSp>
+        <p:nvCxnSpPr>
+          <p:cNvPr id="19" name="Connector 18"/>
+          <p:cNvCxnSpPr/>
+          <p:nvPr/>
+        </p:nvCxnSpPr>
+        <p:spPr>
+          <a:xfrm>
+            <a:off x="4567427" y="3785615"/>
+            <a:ext cx="1020014" cy="109729"/>
+          </a:xfrm>
+          <a:prstGeom prst="line">
+            <a:avLst/>
+          </a:prstGeom>
+          <a:ln w="31750">
+            <a:solidFill>
+              <a:srgbClr val="EB6834"/>
+            </a:solidFill>
+          </a:ln>
+        </p:spPr>
+      </p:cxnSp>
+      <p:sp>
+        <p:nvSpPr>
+          <p:cNvPr id="20" name="Oval 19"/>
+          <p:cNvSpPr/>
+          <p:nvPr/>
+        </p:nvSpPr>
+        <p:spPr>
+          <a:xfrm>
+            <a:off x="2538374" y="2665476"/>
+            <a:ext cx="155448" cy="155448"/>
+          </a:xfrm>
+          <a:prstGeom prst="ellipse">
+            <a:avLst/>
+          </a:prstGeom>
+          <a:solidFill>
+            <a:srgbClr val="AEB4B0"/>
+          </a:solidFill>
+          <a:ln>
+            <a:noFill/>
+          </a:ln>
+        </p:spPr>
+        <p:txBody>
+          <a:bodyPr rtlCol="0" anchor="ctr"/>
+          <a:lstStyle/>
+          <a:p>
+            <a:pPr algn="ctr"/>
+          </a:p>
+        </p:txBody>
+      </p:sp>
+      <p:sp>
+        <p:nvSpPr>
+          <p:cNvPr id="21" name="Oval 20"/>
+          <p:cNvSpPr/>
+          <p:nvPr/>
+        </p:nvSpPr>
+        <p:spPr>
+          <a:xfrm>
+            <a:off x="3824478" y="3104388"/>
+            <a:ext cx="155448" cy="155448"/>
+          </a:xfrm>
+          <a:prstGeom prst="ellipse">
+            <a:avLst/>
+          </a:prstGeom>
+          <a:solidFill>
+            <a:srgbClr val="AEB4B0"/>
+          </a:solidFill>
+          <a:ln>
+            <a:noFill/>
+          </a:ln>
+        </p:spPr>
+        <p:txBody>
+          <a:bodyPr rtlCol="0" anchor="ctr"/>
+          <a:lstStyle/>
+          <a:p>
+            <a:pPr algn="ctr"/>
+          </a:p>
+        </p:txBody>
+      </p:sp>
+      <p:sp>
+        <p:nvSpPr>
+          <p:cNvPr id="22" name="Oval 21"/>
+          <p:cNvSpPr/>
+          <p:nvPr/>
+        </p:nvSpPr>
+        <p:spPr>
+          <a:xfrm>
+            <a:off x="5021884" y="3360420"/>
+            <a:ext cx="155448" cy="155448"/>
+          </a:xfrm>
+          <a:prstGeom prst="ellipse">
+            <a:avLst/>
+          </a:prstGeom>
+          <a:solidFill>
+            <a:srgbClr val="AEB4B0"/>
+          </a:solidFill>
+          <a:ln>
+            <a:noFill/>
+          </a:ln>
+        </p:spPr>
+        <p:txBody>
+          <a:bodyPr rtlCol="0" anchor="ctr"/>
+          <a:lstStyle/>
+          <a:p>
+            <a:pPr algn="ctr"/>
+          </a:p>
+        </p:txBody>
+      </p:sp>
+      <p:sp>
+        <p:nvSpPr>
+          <p:cNvPr id="23" name="Oval 22"/>
+          <p:cNvSpPr/>
+          <p:nvPr/>
+        </p:nvSpPr>
+        <p:spPr>
+          <a:xfrm>
+            <a:off x="4401007" y="2738628"/>
+            <a:ext cx="155448" cy="155448"/>
+          </a:xfrm>
+          <a:prstGeom prst="ellipse">
+            <a:avLst/>
+          </a:prstGeom>
+          <a:solidFill>
+            <a:srgbClr val="AEB4B0"/>
+          </a:solidFill>
+          <a:ln>
+            <a:noFill/>
+          </a:ln>
+        </p:spPr>
+        <p:txBody>
+          <a:bodyPr rtlCol="0" anchor="ctr"/>
+          <a:lstStyle/>
+          <a:p>
+            <a:pPr algn="ctr"/>
+          </a:p>
+        </p:txBody>
+      </p:sp>
+      <p:sp>
+        <p:nvSpPr>
+          <p:cNvPr id="24" name="Oval 23"/>
+          <p:cNvSpPr/>
+          <p:nvPr/>
+        </p:nvSpPr>
+        <p:spPr>
+          <a:xfrm>
+            <a:off x="5598413" y="3177540"/>
+            <a:ext cx="155448" cy="155448"/>
+          </a:xfrm>
+          <a:prstGeom prst="ellipse">
+            <a:avLst/>
+          </a:prstGeom>
+          <a:solidFill>
+            <a:srgbClr val="AEB4B0"/>
+          </a:solidFill>
+          <a:ln>
+            <a:noFill/>
+          </a:ln>
+        </p:spPr>
+        <p:txBody>
+          <a:bodyPr rtlCol="0" anchor="ctr"/>
+          <a:lstStyle/>
+          <a:p>
+            <a:pPr algn="ctr"/>
+          </a:p>
+        </p:txBody>
+      </p:sp>
+      <p:sp>
+        <p:nvSpPr>
+          <p:cNvPr id="25" name="Oval 24"/>
+          <p:cNvSpPr/>
+          <p:nvPr/>
+        </p:nvSpPr>
+        <p:spPr>
+          <a:xfrm>
+            <a:off x="3247948" y="2884932"/>
+            <a:ext cx="155448" cy="155448"/>
+          </a:xfrm>
+          <a:prstGeom prst="ellipse">
+            <a:avLst/>
+          </a:prstGeom>
+          <a:solidFill>
+            <a:srgbClr val="AEB4B0"/>
+          </a:solidFill>
+          <a:ln>
+            <a:noFill/>
+          </a:ln>
+        </p:spPr>
+        <p:txBody>
+          <a:bodyPr rtlCol="0" anchor="ctr"/>
+          <a:lstStyle/>
+          <a:p>
+            <a:pPr algn="ctr"/>
+          </a:p>
+        </p:txBody>
+      </p:sp>
+      <p:sp>
+        <p:nvSpPr>
+          <p:cNvPr id="26" name="Oval 25"/>
+          <p:cNvSpPr/>
+          <p:nvPr/>
+        </p:nvSpPr>
+        <p:spPr>
+          <a:xfrm>
+            <a:off x="1597913" y="2564892"/>
+            <a:ext cx="173736" cy="173736"/>
+          </a:xfrm>
+          <a:prstGeom prst="ellipse">
+            <a:avLst/>
+          </a:prstGeom>
+          <a:solidFill>
+            <a:srgbClr val="EB6834"/>
+          </a:solidFill>
+          <a:ln>
+            <a:noFill/>
+          </a:ln>
+        </p:spPr>
+        <p:txBody>
+          <a:bodyPr rtlCol="0" anchor="ctr"/>
+          <a:lstStyle/>
+          <a:p>
+            <a:pPr algn="ctr"/>
+          </a:p>
+        </p:txBody>
+      </p:sp>
+      <p:sp>
+        <p:nvSpPr>
+          <p:cNvPr id="27" name="Oval 26"/>
+          <p:cNvSpPr/>
+          <p:nvPr/>
+        </p:nvSpPr>
+        <p:spPr>
+          <a:xfrm>
+            <a:off x="2085746" y="2985516"/>
+            <a:ext cx="173736" cy="173736"/>
+          </a:xfrm>
+          <a:prstGeom prst="ellipse">
+            <a:avLst/>
+          </a:prstGeom>
+          <a:solidFill>
+            <a:srgbClr val="EB6834"/>
+          </a:solidFill>
+          <a:ln>
+            <a:noFill/>
+          </a:ln>
+        </p:spPr>
+        <p:txBody>
+          <a:bodyPr rtlCol="0" anchor="ctr"/>
+          <a:lstStyle/>
+          <a:p>
+            <a:pPr algn="ctr"/>
+          </a:p>
+        </p:txBody>
+      </p:sp>
+      <p:sp>
+        <p:nvSpPr>
+          <p:cNvPr id="28" name="Oval 27"/>
+          <p:cNvSpPr/>
+          <p:nvPr/>
+        </p:nvSpPr>
+        <p:spPr>
+          <a:xfrm>
+            <a:off x="2706623" y="3296412"/>
+            <a:ext cx="173736" cy="173736"/>
+          </a:xfrm>
+          <a:prstGeom prst="ellipse">
+            <a:avLst/>
+          </a:prstGeom>
+          <a:solidFill>
+            <a:srgbClr val="EB6834"/>
+          </a:solidFill>
+          <a:ln>
+            <a:noFill/>
+          </a:ln>
+        </p:spPr>
+        <p:txBody>
+          <a:bodyPr rtlCol="0" anchor="ctr"/>
+          <a:lstStyle/>
+          <a:p>
+            <a:pPr algn="ctr"/>
+          </a:p>
+        </p:txBody>
+      </p:sp>
+      <p:sp>
+        <p:nvSpPr>
+          <p:cNvPr id="29" name="Oval 28"/>
+          <p:cNvSpPr/>
+          <p:nvPr/>
+        </p:nvSpPr>
+        <p:spPr>
+          <a:xfrm>
+            <a:off x="3504895" y="3534156"/>
+            <a:ext cx="173736" cy="173736"/>
+          </a:xfrm>
+          <a:prstGeom prst="ellipse">
+            <a:avLst/>
+          </a:prstGeom>
+          <a:solidFill>
+            <a:srgbClr val="EB6834"/>
+          </a:solidFill>
+          <a:ln>
+            <a:noFill/>
+          </a:ln>
+        </p:spPr>
+        <p:txBody>
+          <a:bodyPr rtlCol="0" anchor="ctr"/>
+          <a:lstStyle/>
+          <a:p>
+            <a:pPr algn="ctr"/>
+          </a:p>
+        </p:txBody>
+      </p:sp>
+      <p:sp>
+        <p:nvSpPr>
+          <p:cNvPr id="30" name="Oval 29"/>
+          <p:cNvSpPr/>
+          <p:nvPr/>
+        </p:nvSpPr>
+        <p:spPr>
+          <a:xfrm>
+            <a:off x="4480559" y="3698748"/>
+            <a:ext cx="173736" cy="173736"/>
+          </a:xfrm>
+          <a:prstGeom prst="ellipse">
+            <a:avLst/>
+          </a:prstGeom>
+          <a:solidFill>
+            <a:srgbClr val="EB6834"/>
+          </a:solidFill>
+          <a:ln>
+            <a:noFill/>
+          </a:ln>
+        </p:spPr>
+        <p:txBody>
+          <a:bodyPr rtlCol="0" anchor="ctr"/>
+          <a:lstStyle/>
+          <a:p>
+            <a:pPr algn="ctr"/>
+          </a:p>
+        </p:txBody>
+      </p:sp>
+      <p:sp>
+        <p:nvSpPr>
+          <p:cNvPr id="31" name="Oval 30"/>
+          <p:cNvSpPr/>
+          <p:nvPr/>
+        </p:nvSpPr>
+        <p:spPr>
+          <a:xfrm>
+            <a:off x="5500573" y="3808476"/>
+            <a:ext cx="173736" cy="173736"/>
+          </a:xfrm>
+          <a:prstGeom prst="ellipse">
+            <a:avLst/>
+          </a:prstGeom>
+          <a:solidFill>
+            <a:srgbClr val="EB6834"/>
+          </a:solidFill>
+          <a:ln>
+            <a:noFill/>
+          </a:ln>
+        </p:spPr>
+        <p:txBody>
+          <a:bodyPr rtlCol="0" anchor="ctr"/>
+          <a:lstStyle/>
+          <a:p>
+            <a:pPr algn="ctr"/>
+          </a:p>
+        </p:txBody>
+      </p:sp>
+      <p:sp>
+        <p:nvSpPr>
+          <p:cNvPr id="32" name="TextBox 31"/>
+          <p:cNvSpPr txBox="1"/>
+          <p:nvPr/>
+        </p:nvSpPr>
+        <p:spPr>
+          <a:xfrm>
+            <a:off x="2409444" y="3401568"/>
+            <a:ext cx="274320" cy="292608"/>
+          </a:xfrm>
+          <a:prstGeom prst="rect">
+            <a:avLst/>
+          </a:prstGeom>
+          <a:noFill/>
+        </p:spPr>
+        <p:txBody>
+          <a:bodyPr wrap="square" lIns="0" rIns="0" tIns="0" bIns="0" anchor="t">
+            <a:noAutofit/>
+          </a:bodyPr>
+          <a:lstStyle/>
+          <a:p>
+            <a:pPr algn="r">
+              <a:lnSpc>
+                <a:spcPct val="100000"/>
+              </a:lnSpc>
+              <a:spcBef>
+                <a:spcPts val="0"/>
+              </a:spcBef>
+              <a:spcAft>
+                <a:spcPts val="0"/>
+              </a:spcAft>
+            </a:pPr>
+            <a:r>
+              <a:rPr sz="1600" b="1" i="0">
+                <a:solidFill>
+                  <a:srgbClr val="17201B"/>
+                </a:solidFill>
+                <a:latin typeface="Open Sans"/>
+              </a:rPr>
+              <a:t>A</a:t>
+            </a:r>
+          </a:p>
+        </p:txBody>
+      </p:sp>
+      <p:sp>
+        <p:nvSpPr>
+          <p:cNvPr id="33" name="TextBox 32"/>
+          <p:cNvSpPr txBox="1"/>
+          <p:nvPr/>
+        </p:nvSpPr>
+        <p:spPr>
+          <a:xfrm>
+            <a:off x="4011930" y="2834640"/>
+            <a:ext cx="274320" cy="292608"/>
+          </a:xfrm>
+          <a:prstGeom prst="rect">
+            <a:avLst/>
+          </a:prstGeom>
+          <a:noFill/>
+        </p:spPr>
+        <p:txBody>
+          <a:bodyPr wrap="square" lIns="0" rIns="0" tIns="0" bIns="0" anchor="t">
+            <a:noAutofit/>
+          </a:bodyPr>
+          <a:lstStyle/>
+          <a:p>
+            <a:pPr algn="l">
+              <a:lnSpc>
+                <a:spcPct val="100000"/>
+              </a:lnSpc>
+              <a:spcBef>
+                <a:spcPts val="0"/>
+              </a:spcBef>
+              <a:spcAft>
+                <a:spcPts val="0"/>
+              </a:spcAft>
+            </a:pPr>
+            <a:r>
+              <a:rPr sz="1600" b="1" i="0">
+                <a:solidFill>
+                  <a:srgbClr val="17201B"/>
+                </a:solidFill>
+                <a:latin typeface="Open Sans"/>
+              </a:rPr>
+              <a:t>B</a:t>
+            </a:r>
+          </a:p>
+        </p:txBody>
+      </p:sp>
+      <p:sp>
+        <p:nvSpPr>
+          <p:cNvPr id="34" name="TextBox 33"/>
+          <p:cNvSpPr txBox="1"/>
+          <p:nvPr/>
+        </p:nvSpPr>
+        <p:spPr>
+          <a:xfrm>
+            <a:off x="3059582" y="3749039"/>
+            <a:ext cx="1188720" cy="292608"/>
+          </a:xfrm>
+          <a:prstGeom prst="rect">
+            <a:avLst/>
+          </a:prstGeom>
+          <a:noFill/>
+        </p:spPr>
+        <p:txBody>
+          <a:bodyPr wrap="square" lIns="0" rIns="0" tIns="0" bIns="0" anchor="t">
+            <a:noAutofit/>
+          </a:bodyPr>
+          <a:lstStyle/>
+          <a:p>
+            <a:pPr algn="l">
+              <a:lnSpc>
+                <a:spcPct val="100000"/>
+              </a:lnSpc>
+              <a:spcBef>
+                <a:spcPts val="0"/>
+              </a:spcBef>
+              <a:spcAft>
+                <a:spcPts val="0"/>
+              </a:spcAft>
+            </a:pPr>
+            <a:r>
+              <a:rPr sz="1500" b="1" i="0">
+                <a:solidFill>
+                  <a:srgbClr val="EB6834"/>
+                </a:solidFill>
+                <a:latin typeface="Open Sans"/>
+              </a:rPr>
+              <a:t>fronteira</a:t>
+            </a:r>
+          </a:p>
+        </p:txBody>
+      </p:sp>
+      <p:sp>
+        <p:nvSpPr>
+          <p:cNvPr id="35" name="TextBox 34"/>
+          <p:cNvSpPr txBox="1"/>
+          <p:nvPr/>
+        </p:nvSpPr>
+        <p:spPr>
+          <a:xfrm>
+            <a:off x="3987241" y="4041648"/>
+            <a:ext cx="1691640" cy="475488"/>
+          </a:xfrm>
+          <a:prstGeom prst="rect">
+            <a:avLst/>
+          </a:prstGeom>
+          <a:noFill/>
+        </p:spPr>
+        <p:txBody>
+          <a:bodyPr wrap="square" lIns="0" rIns="0" tIns="0" bIns="0" anchor="t">
+            <a:noAutofit/>
+          </a:bodyPr>
+          <a:lstStyle/>
+          <a:p>
+            <a:pPr algn="r">
+              <a:lnSpc>
+                <a:spcPct val="100000"/>
+              </a:lnSpc>
+              <a:spcBef>
+                <a:spcPts val="0"/>
+              </a:spcBef>
+              <a:spcAft>
+                <a:spcPts val="0"/>
+              </a:spcAft>
+            </a:pPr>
+            <a:r>
+              <a:rPr sz="1300" b="1" i="0">
+                <a:solidFill>
+                  <a:srgbClr val="17201B"/>
+                </a:solidFill>
+                <a:latin typeface="Open Sans"/>
+              </a:rPr>
+              <a:t>menor desvio:</a:t>
+            </a:r>
+          </a:p>
+          <a:p>
+            <a:pPr algn="r">
+              <a:lnSpc>
+                <a:spcPct val="100000"/>
+              </a:lnSpc>
+              <a:spcBef>
+                <a:spcPts val="0"/>
+              </a:spcBef>
+              <a:spcAft>
+                <a:spcPts val="0"/>
+              </a:spcAft>
+            </a:pPr>
+            <a:r>
+              <a:rPr sz="1300" b="1" i="0">
+                <a:solidFill>
+                  <a:srgbClr val="17201B"/>
+                </a:solidFill>
+                <a:latin typeface="Open Sans"/>
+              </a:rPr>
+              <a:t>ninguém o domina</a:t>
+            </a:r>
+          </a:p>
+        </p:txBody>
+      </p:sp>
+      <p:sp>
+        <p:nvSpPr>
+          <p:cNvPr id="36" name="TextBox 35"/>
+          <p:cNvSpPr txBox="1"/>
+          <p:nvPr/>
+        </p:nvSpPr>
+        <p:spPr>
+          <a:xfrm>
+            <a:off x="868680" y="4873752"/>
+            <a:ext cx="5394959" cy="640080"/>
+          </a:xfrm>
+          <a:prstGeom prst="rect">
+            <a:avLst/>
+          </a:prstGeom>
+          <a:noFill/>
+        </p:spPr>
+        <p:txBody>
+          <a:bodyPr wrap="square" lIns="0" rIns="0" tIns="0" bIns="0" anchor="t">
+            <a:noAutofit/>
+          </a:bodyPr>
+          <a:lstStyle/>
+          <a:p>
+            <a:pPr algn="l">
+              <a:lnSpc>
+                <a:spcPct val="100000"/>
+              </a:lnSpc>
+              <a:spcBef>
+                <a:spcPts val="0"/>
+              </a:spcBef>
+              <a:spcAft>
+                <a:spcPts val="0"/>
+              </a:spcAft>
+            </a:pPr>
+            <a:r>
+              <a:rPr sz="1500" b="1" i="0">
+                <a:solidFill>
+                  <a:srgbClr val="17201B"/>
+                </a:solidFill>
+                <a:latin typeface="Open Sans"/>
+              </a:rPr>
+              <a:t>A domina B: </a:t>
+            </a:r>
+            <a:r>
+              <a:rPr sz="1500" b="0" i="0">
+                <a:solidFill>
+                  <a:srgbClr val="4A524D"/>
+                </a:solidFill>
+                <a:latin typeface="Open Sans"/>
+              </a:rPr>
+              <a:t>não é pior em nenhum dos dois termos e é melhor em pelo menos um</a:t>
+            </a:r>
+          </a:p>
+        </p:txBody>
+      </p:sp>
+      <p:sp>
+        <p:nvSpPr>
+          <p:cNvPr id="37" name="Rounded Rectangle 36"/>
+          <p:cNvSpPr/>
+          <p:nvPr/>
+        </p:nvSpPr>
+        <p:spPr>
+          <a:xfrm>
+            <a:off x="6812280" y="1709928"/>
+            <a:ext cx="4828032" cy="777240"/>
+          </a:xfrm>
+          <a:prstGeom prst="roundRect">
+            <a:avLst>
+              <a:gd name="adj" fmla="val 14117"/>
             </a:avLst>
           </a:prstGeom>
           <a:solidFill>
@@ -38127,14 +41174,14 @@
       </p:sp>
       <p:sp>
         <p:nvSpPr>
-          <p:cNvPr id="8" name="TextBox 7"/>
+          <p:cNvPr id="38" name="TextBox 37"/>
           <p:cNvSpPr txBox="1"/>
           <p:nvPr/>
         </p:nvSpPr>
         <p:spPr>
           <a:xfrm>
-            <a:off x="777240" y="1865376"/>
-            <a:ext cx="2286000" cy="411480"/>
+            <a:off x="7086600" y="1773936"/>
+            <a:ext cx="4279392" cy="365760"/>
           </a:xfrm>
           <a:prstGeom prst="rect">
             <a:avLst/>
@@ -38159,7 +41206,7 @@
               </a:spcAft>
             </a:pPr>
             <a:r>
-              <a:rPr sz="2100" b="1" i="0">
+              <a:rPr sz="2000" b="1" i="0">
                 <a:solidFill>
                   <a:srgbClr val="2A78D6"/>
                 </a:solidFill>
@@ -38172,14 +41219,14 @@
       </p:sp>
       <p:sp>
         <p:nvSpPr>
-          <p:cNvPr id="9" name="TextBox 8"/>
+          <p:cNvPr id="39" name="TextBox 38"/>
           <p:cNvSpPr txBox="1"/>
           <p:nvPr/>
         </p:nvSpPr>
         <p:spPr>
           <a:xfrm>
-            <a:off x="777240" y="2350008"/>
-            <a:ext cx="2240279" cy="868680"/>
+            <a:off x="7086600" y="2157984"/>
+            <a:ext cx="4279392" cy="292608"/>
           </a:xfrm>
           <a:prstGeom prst="rect">
             <a:avLst/>
@@ -38210,44 +41257,8 @@
                 </a:solidFill>
                 <a:latin typeface="Open Sans"/>
               </a:rPr>
-              <a:t>soma os dois termos</a:t>
-            </a:r>
-          </a:p>
-        </p:txBody>
-      </p:sp>
-      <p:sp>
-        <p:nvSpPr>
-          <p:cNvPr id="10" name="TextBox 9"/>
-          <p:cNvSpPr txBox="1"/>
-          <p:nvPr/>
-        </p:nvSpPr>
-        <p:spPr>
-          <a:xfrm>
-            <a:off x="777240" y="3383279"/>
-            <a:ext cx="2240279" cy="640080"/>
-          </a:xfrm>
-          <a:prstGeom prst="rect">
-            <a:avLst/>
-          </a:prstGeom>
-          <a:noFill/>
-        </p:spPr>
-        <p:txBody>
-          <a:bodyPr wrap="square" lIns="0" rIns="0" tIns="0" bIns="0" anchor="t">
-            <a:noAutofit/>
-          </a:bodyPr>
-          <a:lstStyle/>
-          <a:p>
-            <a:pPr algn="l">
-              <a:lnSpc>
-                <a:spcPct val="100000"/>
-              </a:lnSpc>
-              <a:spcBef>
-                <a:spcPts val="0"/>
-              </a:spcBef>
-              <a:spcAft>
-                <a:spcPts val="0"/>
-              </a:spcAft>
-            </a:pPr>
+              <a:t>soma os dois termos  →  </a:t>
+            </a:r>
             <a:r>
               <a:rPr sz="1600" b="1" i="0">
                 <a:solidFill>
@@ -38262,18 +41273,18 @@
       </p:sp>
       <p:sp>
         <p:nvSpPr>
-          <p:cNvPr id="11" name="Rounded Rectangle 10"/>
+          <p:cNvPr id="40" name="Rounded Rectangle 39"/>
           <p:cNvSpPr/>
           <p:nvPr/>
         </p:nvSpPr>
         <p:spPr>
           <a:xfrm>
-            <a:off x="3361944" y="1709928"/>
-            <a:ext cx="2651760" cy="2377440"/>
+            <a:off x="6812280" y="2624328"/>
+            <a:ext cx="4828032" cy="2057400"/>
           </a:xfrm>
           <a:prstGeom prst="roundRect">
             <a:avLst>
-              <a:gd name="adj" fmla="val 4615"/>
+              <a:gd name="adj" fmla="val 5333"/>
             </a:avLst>
           </a:prstGeom>
           <a:solidFill>
@@ -38293,14 +41304,14 @@
       </p:sp>
       <p:sp>
         <p:nvSpPr>
-          <p:cNvPr id="12" name="TextBox 11"/>
+          <p:cNvPr id="41" name="TextBox 40"/>
           <p:cNvSpPr txBox="1"/>
           <p:nvPr/>
         </p:nvSpPr>
         <p:spPr>
           <a:xfrm>
-            <a:off x="3590544" y="1865376"/>
-            <a:ext cx="2286000" cy="411480"/>
+            <a:off x="7086600" y="2697480"/>
+            <a:ext cx="4279392" cy="365760"/>
           </a:xfrm>
           <a:prstGeom prst="rect">
             <a:avLst/>
@@ -38325,7 +41336,7 @@
               </a:spcAft>
             </a:pPr>
             <a:r>
-              <a:rPr sz="2100" b="1" i="0">
+              <a:rPr sz="2000" b="1" i="0">
                 <a:solidFill>
                   <a:srgbClr val="EB6834"/>
                 </a:solidFill>
@@ -38338,14 +41349,14 @@
       </p:sp>
       <p:sp>
         <p:nvSpPr>
-          <p:cNvPr id="13" name="TextBox 12"/>
+          <p:cNvPr id="42" name="TextBox 41"/>
           <p:cNvSpPr txBox="1"/>
           <p:nvPr/>
         </p:nvSpPr>
         <p:spPr>
           <a:xfrm>
-            <a:off x="3590544" y="2350008"/>
-            <a:ext cx="2240279" cy="868680"/>
+            <a:off x="7086600" y="3127248"/>
+            <a:ext cx="4279392" cy="1481328"/>
           </a:xfrm>
           <a:prstGeom prst="rect">
             <a:avLst/>
@@ -38376,39 +41387,16 @@
                 </a:solidFill>
                 <a:latin typeface="Open Sans"/>
               </a:rPr>
-              <a:t>trata os dois como objetivos separados</a:t>
-            </a:r>
-          </a:p>
-        </p:txBody>
-      </p:sp>
-      <p:sp>
-        <p:nvSpPr>
-          <p:cNvPr id="14" name="TextBox 13"/>
-          <p:cNvSpPr txBox="1"/>
-          <p:nvPr/>
-        </p:nvSpPr>
-        <p:spPr>
-          <a:xfrm>
-            <a:off x="3590544" y="3383279"/>
-            <a:ext cx="2240279" cy="640080"/>
-          </a:xfrm>
-          <a:prstGeom prst="rect">
-            <a:avLst/>
-          </a:prstGeom>
-          <a:noFill/>
-        </p:spPr>
-        <p:txBody>
-          <a:bodyPr wrap="square" lIns="0" rIns="0" tIns="0" bIns="0" anchor="t">
-            <a:noAutofit/>
-          </a:bodyPr>
-          <a:lstStyle/>
+              <a:t>fica com os elencos que ninguém domina e, entre eles, prefere os mais isolados</a:t>
+            </a:r>
+          </a:p>
           <a:p>
             <a:pPr algn="l">
               <a:lnSpc>
                 <a:spcPct val="100000"/>
               </a:lnSpc>
               <a:spcBef>
-                <a:spcPts val="0"/>
+                <a:spcPts val="500"/>
               </a:spcBef>
               <a:spcAft>
                 <a:spcPts val="0"/>
@@ -38424,22 +41412,44 @@
               <a:t>saída: uma fronteira</a:t>
             </a:r>
           </a:p>
-        </p:txBody>
-      </p:sp>
-      <p:sp>
-        <p:nvSpPr>
-          <p:cNvPr id="15" name="Rounded Rectangle 14"/>
+          <a:p>
+            <a:pPr algn="l">
+              <a:lnSpc>
+                <a:spcPct val="100000"/>
+              </a:lnSpc>
+              <a:spcBef>
+                <a:spcPts val="500"/>
+              </a:spcBef>
+              <a:spcAft>
+                <a:spcPts val="0"/>
+              </a:spcAft>
+            </a:pPr>
+            <a:r>
+              <a:rPr sz="1500" b="0" i="0">
+                <a:solidFill>
+                  <a:srgbClr val="4A524D"/>
+                </a:solidFill>
+                <a:latin typeface="Open Sans"/>
+              </a:rPr>
+              <a:t>para comparar, o ponto dela que minimiza a mesma soma</a:t>
+            </a:r>
+          </a:p>
+        </p:txBody>
+      </p:sp>
+      <p:sp>
+        <p:nvSpPr>
+          <p:cNvPr id="43" name="Rounded Rectangle 42"/>
           <p:cNvSpPr/>
           <p:nvPr/>
         </p:nvSpPr>
         <p:spPr>
           <a:xfrm>
-            <a:off x="6175248" y="1709928"/>
-            <a:ext cx="2651760" cy="2377440"/>
+            <a:off x="6812280" y="4818888"/>
+            <a:ext cx="2331720" cy="822960"/>
           </a:xfrm>
           <a:prstGeom prst="roundRect">
             <a:avLst>
-              <a:gd name="adj" fmla="val 4615"/>
+              <a:gd name="adj" fmla="val 13333"/>
             </a:avLst>
           </a:prstGeom>
           <a:solidFill>
@@ -38459,14 +41469,14 @@
       </p:sp>
       <p:sp>
         <p:nvSpPr>
-          <p:cNvPr id="16" name="TextBox 15"/>
+          <p:cNvPr id="44" name="TextBox 43"/>
           <p:cNvSpPr txBox="1"/>
           <p:nvPr/>
         </p:nvSpPr>
         <p:spPr>
           <a:xfrm>
-            <a:off x="6403848" y="1865376"/>
-            <a:ext cx="2286000" cy="411480"/>
+            <a:off x="7013448" y="4873752"/>
+            <a:ext cx="1929384" cy="274320"/>
           </a:xfrm>
           <a:prstGeom prst="rect">
             <a:avLst/>
@@ -38491,7 +41501,7 @@
               </a:spcAft>
             </a:pPr>
             <a:r>
-              <a:rPr sz="2100" b="1" i="0">
+              <a:rPr sz="1600" b="1" i="0">
                 <a:solidFill>
                   <a:srgbClr val="128A5F"/>
                 </a:solidFill>
@@ -38504,14 +41514,14 @@
       </p:sp>
       <p:sp>
         <p:nvSpPr>
-          <p:cNvPr id="17" name="TextBox 16"/>
+          <p:cNvPr id="45" name="TextBox 44"/>
           <p:cNvSpPr txBox="1"/>
           <p:nvPr/>
         </p:nvSpPr>
         <p:spPr>
           <a:xfrm>
-            <a:off x="6403848" y="2350008"/>
-            <a:ext cx="2240279" cy="868680"/>
+            <a:off x="7013448" y="5148072"/>
+            <a:ext cx="1929384" cy="457200"/>
           </a:xfrm>
           <a:prstGeom prst="rect">
             <a:avLst/>
@@ -38536,7 +41546,7 @@
               </a:spcAft>
             </a:pPr>
             <a:r>
-              <a:rPr sz="1600" b="0" i="0">
+              <a:rPr sz="1300" b="0" i="0">
                 <a:solidFill>
                   <a:srgbClr val="17201B"/>
                 </a:solidFill>
@@ -38549,125 +41559,18 @@
       </p:sp>
       <p:sp>
         <p:nvSpPr>
-          <p:cNvPr id="18" name="TextBox 17"/>
-          <p:cNvSpPr txBox="1"/>
-          <p:nvPr/>
-        </p:nvSpPr>
-        <p:spPr>
-          <a:xfrm>
-            <a:off x="6403848" y="3383279"/>
-            <a:ext cx="2240279" cy="640080"/>
-          </a:xfrm>
-          <a:prstGeom prst="rect">
-            <a:avLst/>
-          </a:prstGeom>
-          <a:noFill/>
-        </p:spPr>
-        <p:txBody>
-          <a:bodyPr wrap="square" lIns="0" rIns="0" tIns="0" bIns="0" anchor="t">
-            <a:noAutofit/>
-          </a:bodyPr>
-          <a:lstStyle/>
-          <a:p>
-            <a:pPr algn="l">
-              <a:lnSpc>
-                <a:spcPct val="100000"/>
-              </a:lnSpc>
-              <a:spcBef>
-                <a:spcPts val="0"/>
-              </a:spcBef>
-              <a:spcAft>
-                <a:spcPts val="0"/>
-              </a:spcAft>
-            </a:pPr>
-            <a:r>
-              <a:rPr sz="1600" b="1" i="0">
-                <a:solidFill>
-                  <a:srgbClr val="17201B"/>
-                </a:solidFill>
-                <a:latin typeface="Open Sans"/>
-              </a:rPr>
-              <a:t>saída: um elenco</a:t>
-            </a:r>
-          </a:p>
-        </p:txBody>
-      </p:sp>
-      <p:sp>
-        <p:nvSpPr>
-          <p:cNvPr id="19" name="Rounded Rectangle 18"/>
+          <p:cNvPr id="46" name="Rounded Rectangle 45"/>
           <p:cNvSpPr/>
           <p:nvPr/>
         </p:nvSpPr>
         <p:spPr>
           <a:xfrm>
-            <a:off x="6403848" y="3127248"/>
-            <a:ext cx="1097280" cy="146304"/>
+            <a:off x="9308592" y="4818888"/>
+            <a:ext cx="2331720" cy="822960"/>
           </a:xfrm>
           <a:prstGeom prst="roundRect">
             <a:avLst>
-              <a:gd name="adj" fmla="val 25000"/>
-            </a:avLst>
-          </a:prstGeom>
-          <a:solidFill>
-            <a:srgbClr val="EB6834"/>
-          </a:solidFill>
-          <a:ln>
-            <a:noFill/>
-          </a:ln>
-        </p:spPr>
-        <p:txBody>
-          <a:bodyPr rtlCol="0" anchor="ctr"/>
-          <a:lstStyle/>
-          <a:p>
-            <a:pPr algn="ctr"/>
-          </a:p>
-        </p:txBody>
-      </p:sp>
-      <p:sp>
-        <p:nvSpPr>
-          <p:cNvPr id="20" name="Rounded Rectangle 19"/>
-          <p:cNvSpPr/>
-          <p:nvPr/>
-        </p:nvSpPr>
-        <p:spPr>
-          <a:xfrm>
-            <a:off x="7501128" y="3127248"/>
-            <a:ext cx="1097280" cy="146304"/>
-          </a:xfrm>
-          <a:prstGeom prst="roundRect">
-            <a:avLst>
-              <a:gd name="adj" fmla="val 25000"/>
-            </a:avLst>
-          </a:prstGeom>
-          <a:solidFill>
-            <a:srgbClr val="2A78D6"/>
-          </a:solidFill>
-          <a:ln>
-            <a:noFill/>
-          </a:ln>
-        </p:spPr>
-        <p:txBody>
-          <a:bodyPr rtlCol="0" anchor="ctr"/>
-          <a:lstStyle/>
-          <a:p>
-            <a:pPr algn="ctr"/>
-          </a:p>
-        </p:txBody>
-      </p:sp>
-      <p:sp>
-        <p:nvSpPr>
-          <p:cNvPr id="21" name="Rounded Rectangle 20"/>
-          <p:cNvSpPr/>
-          <p:nvPr/>
-        </p:nvSpPr>
-        <p:spPr>
-          <a:xfrm>
-            <a:off x="8988552" y="1709928"/>
-            <a:ext cx="2651760" cy="2377440"/>
-          </a:xfrm>
-          <a:prstGeom prst="roundRect">
-            <a:avLst>
-              <a:gd name="adj" fmla="val 4615"/>
+              <a:gd name="adj" fmla="val 13333"/>
             </a:avLst>
           </a:prstGeom>
           <a:solidFill>
@@ -38687,14 +41590,14 @@
       </p:sp>
       <p:sp>
         <p:nvSpPr>
-          <p:cNvPr id="22" name="TextBox 21"/>
+          <p:cNvPr id="47" name="TextBox 46"/>
           <p:cNvSpPr txBox="1"/>
           <p:nvPr/>
         </p:nvSpPr>
         <p:spPr>
           <a:xfrm>
-            <a:off x="9217152" y="1865376"/>
-            <a:ext cx="2286000" cy="411480"/>
+            <a:off x="9509760" y="4873752"/>
+            <a:ext cx="1929384" cy="274320"/>
           </a:xfrm>
           <a:prstGeom prst="rect">
             <a:avLst/>
@@ -38719,7 +41622,7 @@
               </a:spcAft>
             </a:pPr>
             <a:r>
-              <a:rPr sz="2100" b="1" i="0">
+              <a:rPr sz="1600" b="1" i="0">
                 <a:solidFill>
                   <a:srgbClr val="52514E"/>
                 </a:solidFill>
@@ -38732,14 +41635,14 @@
       </p:sp>
       <p:sp>
         <p:nvSpPr>
-          <p:cNvPr id="23" name="TextBox 22"/>
+          <p:cNvPr id="48" name="TextBox 47"/>
           <p:cNvSpPr txBox="1"/>
           <p:nvPr/>
         </p:nvSpPr>
         <p:spPr>
           <a:xfrm>
-            <a:off x="9217152" y="2350008"/>
-            <a:ext cx="2240279" cy="868680"/>
+            <a:off x="9509760" y="5148072"/>
+            <a:ext cx="1929384" cy="457200"/>
           </a:xfrm>
           <a:prstGeom prst="rect">
             <a:avLst/>
@@ -38764,7 +41667,7 @@
               </a:spcAft>
             </a:pPr>
             <a:r>
-              <a:rPr sz="1600" b="0" i="0">
+              <a:rPr sz="1300" b="0" i="0">
                 <a:solidFill>
                   <a:srgbClr val="17201B"/>
                 </a:solidFill>
@@ -38777,14 +41680,14 @@
       </p:sp>
       <p:sp>
         <p:nvSpPr>
-          <p:cNvPr id="24" name="TextBox 23"/>
+          <p:cNvPr id="49" name="TextBox 48"/>
           <p:cNvSpPr txBox="1"/>
           <p:nvPr/>
         </p:nvSpPr>
         <p:spPr>
           <a:xfrm>
-            <a:off x="9217152" y="3383279"/>
-            <a:ext cx="2240279" cy="640080"/>
+            <a:off x="548640" y="5852160"/>
+            <a:ext cx="11091672" cy="347472"/>
           </a:xfrm>
           <a:prstGeom prst="rect">
             <a:avLst/>
@@ -38809,418 +41712,13 @@
               </a:spcAft>
             </a:pPr>
             <a:r>
-              <a:rPr sz="1600" b="1" i="0">
-                <a:solidFill>
-                  <a:srgbClr val="17201B"/>
-                </a:solidFill>
-                <a:latin typeface="Open Sans"/>
-              </a:rPr>
-              <a:t>isola o efeito do termo</a:t>
-            </a:r>
-          </a:p>
-        </p:txBody>
-      </p:sp>
-      <p:sp>
-        <p:nvSpPr>
-          <p:cNvPr id="25" name="TextBox 24"/>
-          <p:cNvSpPr txBox="1"/>
-          <p:nvPr/>
-        </p:nvSpPr>
-        <p:spPr>
-          <a:xfrm>
-            <a:off x="594360" y="4297680"/>
-            <a:ext cx="2560320" cy="621792"/>
-          </a:xfrm>
-          <a:prstGeom prst="rect">
-            <a:avLst/>
-          </a:prstGeom>
-          <a:noFill/>
-        </p:spPr>
-        <p:txBody>
-          <a:bodyPr wrap="square" lIns="0" rIns="0" tIns="0" bIns="0" anchor="t">
-            <a:noAutofit/>
-          </a:bodyPr>
-          <a:lstStyle/>
-          <a:p>
-            <a:pPr algn="l">
-              <a:lnSpc>
-                <a:spcPct val="100000"/>
-              </a:lnSpc>
-              <a:spcBef>
-                <a:spcPts val="0"/>
-              </a:spcBef>
-              <a:spcAft>
-                <a:spcPts val="0"/>
-              </a:spcAft>
-            </a:pPr>
-            <a:r>
-              <a:rPr sz="3400" b="1" i="0">
-                <a:solidFill>
-                  <a:srgbClr val="17201B"/>
-                </a:solidFill>
-                <a:latin typeface="Open Sans"/>
-              </a:rPr>
-              <a:t>300 × 150</a:t>
-            </a:r>
-          </a:p>
-        </p:txBody>
-      </p:sp>
-      <p:sp>
-        <p:nvSpPr>
-          <p:cNvPr id="26" name="TextBox 25"/>
-          <p:cNvSpPr txBox="1"/>
-          <p:nvPr/>
-        </p:nvSpPr>
-        <p:spPr>
-          <a:xfrm>
-            <a:off x="594360" y="4937760"/>
-            <a:ext cx="2560320" cy="685800"/>
-          </a:xfrm>
-          <a:prstGeom prst="rect">
-            <a:avLst/>
-          </a:prstGeom>
-          <a:noFill/>
-        </p:spPr>
-        <p:txBody>
-          <a:bodyPr wrap="square" lIns="0" rIns="0" tIns="0" bIns="0" anchor="t">
-            <a:noAutofit/>
-          </a:bodyPr>
-          <a:lstStyle/>
-          <a:p>
-            <a:pPr algn="l">
-              <a:lnSpc>
-                <a:spcPct val="100000"/>
-              </a:lnSpc>
-              <a:spcBef>
-                <a:spcPts val="0"/>
-              </a:spcBef>
-              <a:spcAft>
-                <a:spcPts val="0"/>
-              </a:spcAft>
-            </a:pPr>
-            <a:r>
-              <a:rPr sz="1500" b="0" i="0">
-                <a:solidFill>
-                  <a:srgbClr val="4A524D"/>
-                </a:solidFill>
-                <a:latin typeface="Open Sans"/>
-              </a:rPr>
-              <a:t>elencos × gerações, em todos os braços</a:t>
-            </a:r>
-          </a:p>
-        </p:txBody>
-      </p:sp>
-      <p:sp>
-        <p:nvSpPr>
-          <p:cNvPr id="27" name="TextBox 26"/>
-          <p:cNvSpPr txBox="1"/>
-          <p:nvPr/>
-        </p:nvSpPr>
-        <p:spPr>
-          <a:xfrm>
-            <a:off x="3407664" y="4297680"/>
-            <a:ext cx="2560320" cy="621792"/>
-          </a:xfrm>
-          <a:prstGeom prst="rect">
-            <a:avLst/>
-          </a:prstGeom>
-          <a:noFill/>
-        </p:spPr>
-        <p:txBody>
-          <a:bodyPr wrap="square" lIns="0" rIns="0" tIns="0" bIns="0" anchor="t">
-            <a:noAutofit/>
-          </a:bodyPr>
-          <a:lstStyle/>
-          <a:p>
-            <a:pPr algn="l">
-              <a:lnSpc>
-                <a:spcPct val="100000"/>
-              </a:lnSpc>
-              <a:spcBef>
-                <a:spcPts val="0"/>
-              </a:spcBef>
-              <a:spcAft>
-                <a:spcPts val="0"/>
-              </a:spcAft>
-            </a:pPr>
-            <a:r>
-              <a:rPr sz="3400" b="1" i="0">
-                <a:solidFill>
-                  <a:srgbClr val="17201B"/>
-                </a:solidFill>
-                <a:latin typeface="Open Sans"/>
-              </a:rPr>
-              <a:t>20</a:t>
-            </a:r>
-          </a:p>
-        </p:txBody>
-      </p:sp>
-      <p:sp>
-        <p:nvSpPr>
-          <p:cNvPr id="28" name="TextBox 27"/>
-          <p:cNvSpPr txBox="1"/>
-          <p:nvPr/>
-        </p:nvSpPr>
-        <p:spPr>
-          <a:xfrm>
-            <a:off x="3407664" y="4937760"/>
-            <a:ext cx="2560320" cy="685800"/>
-          </a:xfrm>
-          <a:prstGeom prst="rect">
-            <a:avLst/>
-          </a:prstGeom>
-          <a:noFill/>
-        </p:spPr>
-        <p:txBody>
-          <a:bodyPr wrap="square" lIns="0" rIns="0" tIns="0" bIns="0" anchor="t">
-            <a:noAutofit/>
-          </a:bodyPr>
-          <a:lstStyle/>
-          <a:p>
-            <a:pPr algn="l">
-              <a:lnSpc>
-                <a:spcPct val="100000"/>
-              </a:lnSpc>
-              <a:spcBef>
-                <a:spcPts val="0"/>
-              </a:spcBef>
-              <a:spcAft>
-                <a:spcPts val="0"/>
-              </a:spcAft>
-            </a:pPr>
-            <a:r>
-              <a:rPr sz="1500" b="0" i="0">
-                <a:solidFill>
-                  <a:srgbClr val="4A524D"/>
-                </a:solidFill>
-                <a:latin typeface="Open Sans"/>
-              </a:rPr>
-              <a:t>execuções por braço, com as mesmas sementes</a:t>
-            </a:r>
-          </a:p>
-        </p:txBody>
-      </p:sp>
-      <p:sp>
-        <p:nvSpPr>
-          <p:cNvPr id="29" name="TextBox 28"/>
-          <p:cNvSpPr txBox="1"/>
-          <p:nvPr/>
-        </p:nvSpPr>
-        <p:spPr>
-          <a:xfrm>
-            <a:off x="6220968" y="4297680"/>
-            <a:ext cx="2560320" cy="621792"/>
-          </a:xfrm>
-          <a:prstGeom prst="rect">
-            <a:avLst/>
-          </a:prstGeom>
-          <a:noFill/>
-        </p:spPr>
-        <p:txBody>
-          <a:bodyPr wrap="square" lIns="0" rIns="0" tIns="0" bIns="0" anchor="t">
-            <a:noAutofit/>
-          </a:bodyPr>
-          <a:lstStyle/>
-          <a:p>
-            <a:pPr algn="l">
-              <a:lnSpc>
-                <a:spcPct val="100000"/>
-              </a:lnSpc>
-              <a:spcBef>
-                <a:spcPts val="0"/>
-              </a:spcBef>
-              <a:spcAft>
-                <a:spcPts val="0"/>
-              </a:spcAft>
-            </a:pPr>
-            <a:r>
-              <a:rPr sz="3400" b="1" i="0">
-                <a:solidFill>
-                  <a:srgbClr val="17201B"/>
-                </a:solidFill>
-                <a:latin typeface="Open Sans"/>
-              </a:rPr>
-              <a:t>1.000</a:t>
-            </a:r>
-          </a:p>
-        </p:txBody>
-      </p:sp>
-      <p:sp>
-        <p:nvSpPr>
-          <p:cNvPr id="30" name="TextBox 29"/>
-          <p:cNvSpPr txBox="1"/>
-          <p:nvPr/>
-        </p:nvSpPr>
-        <p:spPr>
-          <a:xfrm>
-            <a:off x="6220968" y="4937760"/>
-            <a:ext cx="2560320" cy="685800"/>
-          </a:xfrm>
-          <a:prstGeom prst="rect">
-            <a:avLst/>
-          </a:prstGeom>
-          <a:noFill/>
-        </p:spPr>
-        <p:txBody>
-          <a:bodyPr wrap="square" lIns="0" rIns="0" tIns="0" bIns="0" anchor="t">
-            <a:noAutofit/>
-          </a:bodyPr>
-          <a:lstStyle/>
-          <a:p>
-            <a:pPr algn="l">
-              <a:lnSpc>
-                <a:spcPct val="100000"/>
-              </a:lnSpc>
-              <a:spcBef>
-                <a:spcPts val="0"/>
-              </a:spcBef>
-              <a:spcAft>
-                <a:spcPts val="0"/>
-              </a:spcAft>
-            </a:pPr>
-            <a:r>
-              <a:rPr sz="1500" b="0" i="0">
-                <a:solidFill>
-                  <a:srgbClr val="4A524D"/>
-                </a:solidFill>
-                <a:latin typeface="Open Sans"/>
-              </a:rPr>
-              <a:t>lutas por par na reavaliação, em sorteios inéditos</a:t>
-            </a:r>
-          </a:p>
-        </p:txBody>
-      </p:sp>
-      <p:sp>
-        <p:nvSpPr>
-          <p:cNvPr id="31" name="TextBox 30"/>
-          <p:cNvSpPr txBox="1"/>
-          <p:nvPr/>
-        </p:nvSpPr>
-        <p:spPr>
-          <a:xfrm>
-            <a:off x="9034272" y="4297680"/>
-            <a:ext cx="2560320" cy="621792"/>
-          </a:xfrm>
-          <a:prstGeom prst="rect">
-            <a:avLst/>
-          </a:prstGeom>
-          <a:noFill/>
-        </p:spPr>
-        <p:txBody>
-          <a:bodyPr wrap="square" lIns="0" rIns="0" tIns="0" bIns="0" anchor="t">
-            <a:noAutofit/>
-          </a:bodyPr>
-          <a:lstStyle/>
-          <a:p>
-            <a:pPr algn="l">
-              <a:lnSpc>
-                <a:spcPct val="100000"/>
-              </a:lnSpc>
-              <a:spcBef>
-                <a:spcPts val="0"/>
-              </a:spcBef>
-              <a:spcAft>
-                <a:spcPts val="0"/>
-              </a:spcAft>
-            </a:pPr>
-            <a:r>
-              <a:rPr sz="3400" b="1" i="0">
-                <a:solidFill>
-                  <a:srgbClr val="17201B"/>
-                </a:solidFill>
-                <a:latin typeface="Open Sans"/>
-              </a:rPr>
-              <a:t>35</a:t>
-            </a:r>
-          </a:p>
-        </p:txBody>
-      </p:sp>
-      <p:sp>
-        <p:nvSpPr>
-          <p:cNvPr id="32" name="TextBox 31"/>
-          <p:cNvSpPr txBox="1"/>
-          <p:nvPr/>
-        </p:nvSpPr>
-        <p:spPr>
-          <a:xfrm>
-            <a:off x="9034272" y="4937760"/>
-            <a:ext cx="2560320" cy="685800"/>
-          </a:xfrm>
-          <a:prstGeom prst="rect">
-            <a:avLst/>
-          </a:prstGeom>
-          <a:noFill/>
-        </p:spPr>
-        <p:txBody>
-          <a:bodyPr wrap="square" lIns="0" rIns="0" tIns="0" bIns="0" anchor="t">
-            <a:noAutofit/>
-          </a:bodyPr>
-          <a:lstStyle/>
-          <a:p>
-            <a:pPr algn="l">
-              <a:lnSpc>
-                <a:spcPct val="100000"/>
-              </a:lnSpc>
-              <a:spcBef>
-                <a:spcPts val="0"/>
-              </a:spcBef>
-              <a:spcAft>
-                <a:spcPts val="0"/>
-              </a:spcAft>
-            </a:pPr>
-            <a:r>
-              <a:rPr sz="1500" b="0" i="0">
-                <a:solidFill>
-                  <a:srgbClr val="4A524D"/>
-                </a:solidFill>
-                <a:latin typeface="Open Sans"/>
-              </a:rPr>
-              <a:t>elencos nulos como referência de acaso</a:t>
-            </a:r>
-          </a:p>
-        </p:txBody>
-      </p:sp>
-      <p:sp>
-        <p:nvSpPr>
-          <p:cNvPr id="33" name="TextBox 32"/>
-          <p:cNvSpPr txBox="1"/>
-          <p:nvPr/>
-        </p:nvSpPr>
-        <p:spPr>
-          <a:xfrm>
-            <a:off x="548640" y="5733288"/>
-            <a:ext cx="11091672" cy="347472"/>
-          </a:xfrm>
-          <a:prstGeom prst="rect">
-            <a:avLst/>
-          </a:prstGeom>
-          <a:noFill/>
-        </p:spPr>
-        <p:txBody>
-          <a:bodyPr wrap="square" lIns="0" rIns="0" tIns="0" bIns="0" anchor="t">
-            <a:noAutofit/>
-          </a:bodyPr>
-          <a:lstStyle/>
-          <a:p>
-            <a:pPr algn="l">
-              <a:lnSpc>
-                <a:spcPct val="100000"/>
-              </a:lnSpc>
-              <a:spcBef>
-                <a:spcPts val="0"/>
-              </a:spcBef>
-              <a:spcAft>
-                <a:spcPts val="0"/>
-              </a:spcAft>
-            </a:pPr>
-            <a:r>
-              <a:rPr sz="1500" b="0" i="0">
+              <a:rPr sz="1400" b="0" i="0">
                 <a:solidFill>
                   <a:srgbClr val="6F7772"/>
                 </a:solidFill>
                 <a:latin typeface="Open Sans"/>
               </a:rPr>
-              <a:t>Comparações: Wilcoxon pareado, efeito Â₁₂ e correção de Holm</a:t>
+              <a:t>Mesmo orçamento · 20 execuções por braço, mesmas sementes · reavaliação com 1.000 lutas por par · Wilcoxon pareado e Holm</a:t>
             </a:r>
           </a:p>
         </p:txBody>
@@ -39489,7 +41987,7 @@
                 </a:solidFill>
                 <a:latin typeface="Open Sans"/>
               </a:rPr>
-              <a:t>7</a:t>
+              <a:t>8</a:t>
             </a:r>
           </a:p>
         </p:txBody>
@@ -40386,7 +42884,7 @@
                 </a:solidFill>
                 <a:latin typeface="Open Sans"/>
               </a:rPr>
-              <a:t>8</a:t>
+              <a:t>9</a:t>
             </a:r>
           </a:p>
         </p:txBody>
@@ -42104,7 +44602,7 @@
                 </a:solidFill>
                 <a:latin typeface="Open Sans"/>
               </a:rPr>
-              <a:t>9</a:t>
+              <a:t>10</a:t>
             </a:r>
           </a:p>
         </p:txBody>

</xml_diff>